<commit_message>
Updating presentation for extra slides and background slides
</commit_message>
<xml_diff>
--- a/ProposalWriting/Presentation/BoldyProposalDefense [Autosaved].pptx
+++ b/ProposalWriting/Presentation/BoldyProposalDefense [Autosaved].pptx
@@ -433,7 +433,7 @@
           <a:p>
             <a:fld id="{49E120CA-99AD-3943-B60B-43DCF85265B8}" type="datetimeFigureOut">
               <a:rPr lang="en-US" smtClean="0"/>
-              <a:t>10/2/26</a:t>
+              <a:t>10/6/26</a:t>
             </a:fld>
             <a:endParaRPr lang="en-US"/>
           </a:p>
@@ -847,7 +847,7 @@
           <a:p>
             <a:fld id="{B105E061-EB09-174B-A0D5-FC5974A2AFFB}" type="datetime1">
               <a:rPr lang="en-US" smtClean="0"/>
-              <a:t>10/2/26</a:t>
+              <a:t>10/6/26</a:t>
             </a:fld>
             <a:endParaRPr lang="en-US"/>
           </a:p>
@@ -1048,7 +1048,7 @@
           <a:p>
             <a:fld id="{621252E1-B88E-3342-B0A7-CCAE0CA75BBB}" type="datetime1">
               <a:rPr lang="en-US" smtClean="0"/>
-              <a:t>10/2/26</a:t>
+              <a:t>10/6/26</a:t>
             </a:fld>
             <a:endParaRPr lang="en-US"/>
           </a:p>
@@ -1259,7 +1259,7 @@
           <a:p>
             <a:fld id="{EACE6763-50BE-5B49-B87C-4D19468B7C96}" type="datetime1">
               <a:rPr lang="en-US" smtClean="0"/>
-              <a:t>10/2/26</a:t>
+              <a:t>10/6/26</a:t>
             </a:fld>
             <a:endParaRPr lang="en-US"/>
           </a:p>
@@ -1460,7 +1460,7 @@
           <a:p>
             <a:fld id="{63944F94-749A-F843-B6E1-57F25A03E432}" type="datetime1">
               <a:rPr lang="en-US" smtClean="0"/>
-              <a:t>10/2/26</a:t>
+              <a:t>10/6/26</a:t>
             </a:fld>
             <a:endParaRPr lang="en-US"/>
           </a:p>
@@ -1738,7 +1738,7 @@
           <a:p>
             <a:fld id="{993C7A3E-56A5-C84D-976C-B35F3FE89F79}" type="datetime1">
               <a:rPr lang="en-US" smtClean="0"/>
-              <a:t>10/2/26</a:t>
+              <a:t>10/6/26</a:t>
             </a:fld>
             <a:endParaRPr lang="en-US"/>
           </a:p>
@@ -2006,7 +2006,7 @@
           <a:p>
             <a:fld id="{F4B52015-7C28-484D-B145-D28E2A08F900}" type="datetime1">
               <a:rPr lang="en-US" smtClean="0"/>
-              <a:t>10/2/26</a:t>
+              <a:t>10/6/26</a:t>
             </a:fld>
             <a:endParaRPr lang="en-US"/>
           </a:p>
@@ -2421,7 +2421,7 @@
           <a:p>
             <a:fld id="{FCA991B3-1372-E242-8B38-E6436435C338}" type="datetime1">
               <a:rPr lang="en-US" smtClean="0"/>
-              <a:t>10/2/26</a:t>
+              <a:t>10/6/26</a:t>
             </a:fld>
             <a:endParaRPr lang="en-US"/>
           </a:p>
@@ -2565,7 +2565,7 @@
           <a:p>
             <a:fld id="{919EF1DF-064D-3A44-9645-D74AED0CCD60}" type="datetime1">
               <a:rPr lang="en-US" smtClean="0"/>
-              <a:t>10/2/26</a:t>
+              <a:t>10/6/26</a:t>
             </a:fld>
             <a:endParaRPr lang="en-US"/>
           </a:p>
@@ -2681,7 +2681,7 @@
           <a:p>
             <a:fld id="{7802D0E8-747A-794C-8F8A-E949892A428B}" type="datetime1">
               <a:rPr lang="en-US" smtClean="0"/>
-              <a:t>10/2/26</a:t>
+              <a:t>10/6/26</a:t>
             </a:fld>
             <a:endParaRPr lang="en-US"/>
           </a:p>
@@ -2995,7 +2995,7 @@
           <a:p>
             <a:fld id="{6369CB82-7A51-6E4C-81E6-424375AAB724}" type="datetime1">
               <a:rPr lang="en-US" smtClean="0"/>
-              <a:t>10/2/26</a:t>
+              <a:t>10/6/26</a:t>
             </a:fld>
             <a:endParaRPr lang="en-US"/>
           </a:p>
@@ -3286,7 +3286,7 @@
           <a:p>
             <a:fld id="{88931E28-5FD3-854B-AAE6-645D4F1C2615}" type="datetime1">
               <a:rPr lang="en-US" smtClean="0"/>
-              <a:t>10/2/26</a:t>
+              <a:t>10/6/26</a:t>
             </a:fld>
             <a:endParaRPr lang="en-US"/>
           </a:p>
@@ -3530,7 +3530,7 @@
           <a:p>
             <a:fld id="{13B6B83F-07D0-CF48-A32E-56605F2D4971}" type="datetime1">
               <a:rPr lang="en-US" smtClean="0"/>
-              <a:t>10/2/26</a:t>
+              <a:t>10/6/26</a:t>
             </a:fld>
             <a:endParaRPr lang="en-US"/>
           </a:p>
@@ -4174,17 +4174,45 @@
         </p:nvSpPr>
         <p:spPr>
           <a:xfrm>
-            <a:off x="1524000" y="1995558"/>
-            <a:ext cx="9144000" cy="1655762"/>
+            <a:off x="1524000" y="1995557"/>
+            <a:ext cx="9144000" cy="2644681"/>
           </a:xfrm>
         </p:spPr>
         <p:txBody>
-          <a:bodyPr/>
+          <a:bodyPr>
+            <a:normAutofit lnSpcReduction="10000"/>
+          </a:bodyPr>
           <a:lstStyle/>
           <a:p>
             <a:r>
               <a:rPr lang="en-US" dirty="0"/>
               <a:t>Andrew Boldy</a:t>
+            </a:r>
+          </a:p>
+          <a:p>
+            <a:r>
+              <a:rPr lang="en-US" dirty="0"/>
+              <a:t>Major Professor: Dr. Dave Tedeschi</a:t>
+            </a:r>
+          </a:p>
+          <a:p>
+            <a:r>
+              <a:rPr lang="en-US" dirty="0"/>
+              <a:t>USC Committee Members: Dr. Alexey Petrov, Dr. Matthias Schindler</a:t>
+            </a:r>
+          </a:p>
+          <a:p>
+            <a:r>
+              <a:rPr lang="en-US" dirty="0"/>
+              <a:t>External Committee Member: Dr. Bertrand </a:t>
+            </a:r>
+            <a:r>
+              <a:rPr lang="en-US" dirty="0" err="1"/>
+              <a:t>Echenard</a:t>
+            </a:r>
+            <a:r>
+              <a:rPr lang="en-US" dirty="0"/>
+              <a:t> (Cal Tech)</a:t>
             </a:r>
           </a:p>
           <a:p>
@@ -4975,8 +5003,8 @@
           </a:prstGeom>
         </p:spPr>
       </p:pic>
-      <mc:AlternateContent xmlns:mc="http://schemas.openxmlformats.org/markup-compatibility/2006">
-        <mc:Choice xmlns:a14="http://schemas.microsoft.com/office/drawing/2010/main" Requires="a14">
+      <mc:AlternateContent xmlns:mc="http://schemas.openxmlformats.org/markup-compatibility/2006" xmlns:a14="http://schemas.microsoft.com/office/drawing/2010/main">
+        <mc:Choice Requires="a14">
           <p:sp>
             <p:nvSpPr>
               <p:cNvPr id="4" name="Title 1">
@@ -5034,6 +5062,7 @@
                               <a:srgbClr val="C00000"/>
                             </a:solidFill>
                             <a:latin typeface="Cambria Math" panose="02040503050406030204" pitchFamily="18" charset="0"/>
+                            <a:ea typeface="Cambria Math" panose="02040503050406030204" pitchFamily="18" charset="0"/>
                           </a:rPr>
                         </m:ctrlPr>
                       </m:sSupPr>
@@ -5064,7 +5093,7 @@
                     <m:sSup>
                       <m:sSupPr>
                         <m:ctrlPr>
-                          <a:rPr lang="en-US" sz="2800" i="1" smtClean="0">
+                          <a:rPr lang="en-US" sz="2800" b="0" i="1" smtClean="0">
                             <a:solidFill>
                               <a:srgbClr val="C00000"/>
                             </a:solidFill>
@@ -5108,7 +5137,7 @@
                     <m:sSup>
                       <m:sSupPr>
                         <m:ctrlPr>
-                          <a:rPr lang="en-US" sz="2800" i="1" smtClean="0">
+                          <a:rPr lang="en-US" sz="2800" b="0" i="1" smtClean="0">
                             <a:solidFill>
                               <a:srgbClr val="C00000"/>
                             </a:solidFill>
@@ -5145,7 +5174,7 @@
                     <m:sSup>
                       <m:sSupPr>
                         <m:ctrlPr>
-                          <a:rPr lang="en-US" sz="2800" i="1" smtClean="0">
+                          <a:rPr lang="en-US" sz="2800" b="0" i="1" smtClean="0">
                             <a:solidFill>
                               <a:srgbClr val="C00000"/>
                             </a:solidFill>
@@ -5193,7 +5222,7 @@
             </p:txBody>
           </p:sp>
         </mc:Choice>
-        <mc:Fallback>
+        <mc:Fallback xmlns="">
           <p:sp>
             <p:nvSpPr>
               <p:cNvPr id="4" name="Title 1">
@@ -5483,54 +5512,37 @@
       </p:grpSpPr>
       <p:sp>
         <p:nvSpPr>
-          <p:cNvPr id="2" name="Title 1">
-            <a:extLst>
-              <a:ext uri="{FF2B5EF4-FFF2-40B4-BE49-F238E27FC236}">
-                <a16:creationId xmlns:a16="http://schemas.microsoft.com/office/drawing/2014/main" id="{1678ABB6-7B21-3D6E-E425-8864689338D7}"/>
-              </a:ext>
-            </a:extLst>
-          </p:cNvPr>
-          <p:cNvSpPr>
-            <a:spLocks noGrp="1"/>
-          </p:cNvSpPr>
-          <p:nvPr>
-            <p:ph type="title"/>
-          </p:nvPr>
-        </p:nvSpPr>
-        <p:spPr/>
+          <p:cNvPr id="3" name="Content Placeholder 2">
+            <a:extLst>
+              <a:ext uri="{FF2B5EF4-FFF2-40B4-BE49-F238E27FC236}">
+                <a16:creationId xmlns:a16="http://schemas.microsoft.com/office/drawing/2014/main" id="{5C082BC7-D665-4282-10FB-7CD5404EA439}"/>
+              </a:ext>
+            </a:extLst>
+          </p:cNvPr>
+          <p:cNvSpPr>
+            <a:spLocks noGrp="1"/>
+          </p:cNvSpPr>
+          <p:nvPr>
+            <p:ph idx="1"/>
+          </p:nvPr>
+        </p:nvSpPr>
+        <p:spPr>
+          <a:xfrm>
+            <a:off x="0" y="424542"/>
+            <a:ext cx="12192000" cy="5931807"/>
+          </a:xfrm>
+        </p:spPr>
         <p:txBody>
           <a:bodyPr/>
           <a:lstStyle/>
           <a:p>
             <a:r>
               <a:rPr lang="en-US" dirty="0"/>
-              <a:t>Vertexing</a:t>
-            </a:r>
-          </a:p>
-        </p:txBody>
-      </p:sp>
-      <p:sp>
-        <p:nvSpPr>
-          <p:cNvPr id="3" name="Content Placeholder 2">
-            <a:extLst>
-              <a:ext uri="{FF2B5EF4-FFF2-40B4-BE49-F238E27FC236}">
-                <a16:creationId xmlns:a16="http://schemas.microsoft.com/office/drawing/2014/main" id="{5C082BC7-D665-4282-10FB-7CD5404EA439}"/>
-              </a:ext>
-            </a:extLst>
-          </p:cNvPr>
-          <p:cNvSpPr>
-            <a:spLocks noGrp="1"/>
-          </p:cNvSpPr>
-          <p:nvPr>
-            <p:ph idx="1"/>
-          </p:nvPr>
-        </p:nvSpPr>
-        <p:spPr/>
-        <p:txBody>
-          <a:bodyPr/>
-          <a:lstStyle/>
-          <a:p>
-            <a:endParaRPr lang="en-US"/>
+              <a:t>Parameterization of track reconstructions</a:t>
+            </a:r>
+          </a:p>
+          <a:p>
+            <a:endParaRPr lang="en-US" dirty="0"/>
           </a:p>
         </p:txBody>
       </p:sp>
@@ -6191,7 +6203,7 @@
                       <m:accPr>
                         <m:chr m:val="⃑"/>
                         <m:ctrlPr>
-                          <a:rPr lang="en-US" i="1" smtClean="0">
+                          <a:rPr lang="en-US" b="0" i="1" smtClean="0">
                             <a:latin typeface="Cambria Math" panose="02040503050406030204" pitchFamily="18" charset="0"/>
                           </a:rPr>
                         </m:ctrlPr>
@@ -6451,7 +6463,7 @@
                       <m:accPr>
                         <m:chr m:val="⃑"/>
                         <m:ctrlPr>
-                          <a:rPr lang="en-US" i="1" smtClean="0">
+                          <a:rPr lang="en-US" b="0" i="1" smtClean="0">
                             <a:latin typeface="Cambria Math" panose="02040503050406030204" pitchFamily="18" charset="0"/>
                           </a:rPr>
                         </m:ctrlPr>
@@ -7078,7 +7090,7 @@
                       <m:accPr>
                         <m:chr m:val="⃑"/>
                         <m:ctrlPr>
-                          <a:rPr lang="en-US" i="1" smtClean="0">
+                          <a:rPr lang="en-US" b="0" i="1" smtClean="0">
                             <a:latin typeface="Cambria Math" panose="02040503050406030204" pitchFamily="18" charset="0"/>
                           </a:rPr>
                         </m:ctrlPr>
@@ -7382,7 +7394,7 @@
                       <m:accPr>
                         <m:chr m:val="⃑"/>
                         <m:ctrlPr>
-                          <a:rPr lang="en-US" i="1" smtClean="0">
+                          <a:rPr lang="en-US" b="0" i="1" smtClean="0">
                             <a:latin typeface="Cambria Math" panose="02040503050406030204" pitchFamily="18" charset="0"/>
                           </a:rPr>
                         </m:ctrlPr>
@@ -8177,7 +8189,7 @@
                       <m:accPr>
                         <m:chr m:val="⃑"/>
                         <m:ctrlPr>
-                          <a:rPr lang="en-US" i="1" smtClean="0">
+                          <a:rPr lang="en-US" b="0" i="1" smtClean="0">
                             <a:latin typeface="Cambria Math" panose="02040503050406030204" pitchFamily="18" charset="0"/>
                           </a:rPr>
                         </m:ctrlPr>
@@ -8330,7 +8342,7 @@
                       <m:accPr>
                         <m:chr m:val="⃑"/>
                         <m:ctrlPr>
-                          <a:rPr lang="en-US" i="1" smtClean="0">
+                          <a:rPr lang="en-US" b="0" i="1" smtClean="0">
                             <a:latin typeface="Cambria Math" panose="02040503050406030204" pitchFamily="18" charset="0"/>
                           </a:rPr>
                         </m:ctrlPr>
@@ -8483,7 +8495,7 @@
                       <m:accPr>
                         <m:chr m:val="⃑"/>
                         <m:ctrlPr>
-                          <a:rPr lang="en-US" i="1" smtClean="0">
+                          <a:rPr lang="en-US" b="0" i="1" smtClean="0">
                             <a:latin typeface="Cambria Math" panose="02040503050406030204" pitchFamily="18" charset="0"/>
                           </a:rPr>
                         </m:ctrlPr>
@@ -8655,7 +8667,7 @@
                       <m:accPr>
                         <m:chr m:val="⃑"/>
                         <m:ctrlPr>
-                          <a:rPr lang="en-US" i="1" smtClean="0">
+                          <a:rPr lang="en-US" b="0" i="1" smtClean="0">
                             <a:latin typeface="Cambria Math" panose="02040503050406030204" pitchFamily="18" charset="0"/>
                           </a:rPr>
                         </m:ctrlPr>
@@ -8952,15 +8964,12 @@
                 <a:pPr/>
                 <a14:m>
                   <m:oMathPara xmlns:m="http://schemas.openxmlformats.org/officeDocument/2006/math">
-                    <m:oMathParaPr>
-                      <m:jc m:val="centerGroup"/>
-                    </m:oMathParaPr>
-                    <m:oMath xmlns:m="http://schemas.openxmlformats.org/officeDocument/2006/math">
+                    <m:oMath>
                       <m:acc>
                         <m:accPr>
                           <m:chr m:val="⃑"/>
                           <m:ctrlPr>
-                            <a:rPr lang="en-US" i="1" smtClean="0">
+                            <a:rPr lang="en-US" b="0" i="1" smtClean="0">
                               <a:latin typeface="Cambria Math" panose="02040503050406030204" pitchFamily="18" charset="0"/>
                             </a:rPr>
                           </m:ctrlPr>
@@ -10536,54 +10545,31 @@
       </p:grpSpPr>
       <p:sp>
         <p:nvSpPr>
-          <p:cNvPr id="2" name="Title 1">
-            <a:extLst>
-              <a:ext uri="{FF2B5EF4-FFF2-40B4-BE49-F238E27FC236}">
-                <a16:creationId xmlns:a16="http://schemas.microsoft.com/office/drawing/2014/main" id="{93C2AF71-8E34-2CAA-7AB0-F0179C17C2DE}"/>
-              </a:ext>
-            </a:extLst>
-          </p:cNvPr>
-          <p:cNvSpPr>
-            <a:spLocks noGrp="1"/>
-          </p:cNvSpPr>
-          <p:nvPr>
-            <p:ph type="title"/>
-          </p:nvPr>
-        </p:nvSpPr>
-        <p:spPr/>
+          <p:cNvPr id="3" name="Content Placeholder 2">
+            <a:extLst>
+              <a:ext uri="{FF2B5EF4-FFF2-40B4-BE49-F238E27FC236}">
+                <a16:creationId xmlns:a16="http://schemas.microsoft.com/office/drawing/2014/main" id="{80023601-D1BA-D1E2-CE47-90BA3D838FE3}"/>
+              </a:ext>
+            </a:extLst>
+          </p:cNvPr>
+          <p:cNvSpPr>
+            <a:spLocks noGrp="1"/>
+          </p:cNvSpPr>
+          <p:nvPr>
+            <p:ph idx="1"/>
+          </p:nvPr>
+        </p:nvSpPr>
+        <p:spPr>
+          <a:xfrm>
+            <a:off x="0" y="424542"/>
+            <a:ext cx="12192000" cy="5931807"/>
+          </a:xfrm>
+        </p:spPr>
         <p:txBody>
           <a:bodyPr/>
           <a:lstStyle/>
           <a:p>
-            <a:r>
-              <a:rPr lang="en-US" dirty="0"/>
-              <a:t>Toy-Generator Creation and Validation</a:t>
-            </a:r>
-          </a:p>
-        </p:txBody>
-      </p:sp>
-      <p:sp>
-        <p:nvSpPr>
-          <p:cNvPr id="3" name="Content Placeholder 2">
-            <a:extLst>
-              <a:ext uri="{FF2B5EF4-FFF2-40B4-BE49-F238E27FC236}">
-                <a16:creationId xmlns:a16="http://schemas.microsoft.com/office/drawing/2014/main" id="{80023601-D1BA-D1E2-CE47-90BA3D838FE3}"/>
-              </a:ext>
-            </a:extLst>
-          </p:cNvPr>
-          <p:cNvSpPr>
-            <a:spLocks noGrp="1"/>
-          </p:cNvSpPr>
-          <p:nvPr>
-            <p:ph idx="1"/>
-          </p:nvPr>
-        </p:nvSpPr>
-        <p:spPr/>
-        <p:txBody>
-          <a:bodyPr/>
-          <a:lstStyle/>
-          <a:p>
-            <a:endParaRPr lang="en-US"/>
+            <a:endParaRPr lang="en-US" dirty="0"/>
           </a:p>
         </p:txBody>
       </p:sp>
@@ -11011,34 +10997,6 @@
       </p:grpSpPr>
       <p:sp>
         <p:nvSpPr>
-          <p:cNvPr id="2" name="Title 1">
-            <a:extLst>
-              <a:ext uri="{FF2B5EF4-FFF2-40B4-BE49-F238E27FC236}">
-                <a16:creationId xmlns:a16="http://schemas.microsoft.com/office/drawing/2014/main" id="{36DCFFC3-E975-E0F8-4BFD-C28C957E38B1}"/>
-              </a:ext>
-            </a:extLst>
-          </p:cNvPr>
-          <p:cNvSpPr>
-            <a:spLocks noGrp="1"/>
-          </p:cNvSpPr>
-          <p:nvPr>
-            <p:ph type="title"/>
-          </p:nvPr>
-        </p:nvSpPr>
-        <p:spPr/>
-        <p:txBody>
-          <a:bodyPr/>
-          <a:lstStyle/>
-          <a:p>
-            <a:r>
-              <a:rPr lang="en-US" dirty="0"/>
-              <a:t>Analysis Products (from Stops)</a:t>
-            </a:r>
-          </a:p>
-        </p:txBody>
-      </p:sp>
-      <p:sp>
-        <p:nvSpPr>
           <p:cNvPr id="3" name="Content Placeholder 2">
             <a:extLst>
               <a:ext uri="{FF2B5EF4-FFF2-40B4-BE49-F238E27FC236}">
@@ -11053,7 +11011,12 @@
             <p:ph idx="1"/>
           </p:nvPr>
         </p:nvSpPr>
-        <p:spPr/>
+        <p:spPr>
+          <a:xfrm>
+            <a:off x="0" y="424542"/>
+            <a:ext cx="12192000" cy="5931807"/>
+          </a:xfrm>
+        </p:spPr>
         <p:txBody>
           <a:bodyPr/>
           <a:lstStyle/>
@@ -11346,34 +11309,6 @@
       </p:grpSpPr>
       <p:sp>
         <p:nvSpPr>
-          <p:cNvPr id="2" name="Title 1">
-            <a:extLst>
-              <a:ext uri="{FF2B5EF4-FFF2-40B4-BE49-F238E27FC236}">
-                <a16:creationId xmlns:a16="http://schemas.microsoft.com/office/drawing/2014/main" id="{D2E68E33-2728-D6B4-AA72-1603BD572F74}"/>
-              </a:ext>
-            </a:extLst>
-          </p:cNvPr>
-          <p:cNvSpPr>
-            <a:spLocks noGrp="1"/>
-          </p:cNvSpPr>
-          <p:nvPr>
-            <p:ph type="title"/>
-          </p:nvPr>
-        </p:nvSpPr>
-        <p:spPr/>
-        <p:txBody>
-          <a:bodyPr/>
-          <a:lstStyle/>
-          <a:p>
-            <a:r>
-              <a:rPr lang="en-US" dirty="0"/>
-              <a:t>Candidacy Cuts for Vertexing</a:t>
-            </a:r>
-          </a:p>
-        </p:txBody>
-      </p:sp>
-      <p:sp>
-        <p:nvSpPr>
           <p:cNvPr id="3" name="Content Placeholder 2">
             <a:extLst>
               <a:ext uri="{FF2B5EF4-FFF2-40B4-BE49-F238E27FC236}">
@@ -11388,7 +11323,12 @@
             <p:ph idx="1"/>
           </p:nvPr>
         </p:nvSpPr>
-        <p:spPr/>
+        <p:spPr>
+          <a:xfrm>
+            <a:off x="0" y="424542"/>
+            <a:ext cx="12192000" cy="5931807"/>
+          </a:xfrm>
+        </p:spPr>
         <p:txBody>
           <a:bodyPr/>
           <a:lstStyle/>
@@ -11681,38 +11621,6 @@
       </p:grpSpPr>
       <p:sp>
         <p:nvSpPr>
-          <p:cNvPr id="2" name="Title 1">
-            <a:extLst>
-              <a:ext uri="{FF2B5EF4-FFF2-40B4-BE49-F238E27FC236}">
-                <a16:creationId xmlns:a16="http://schemas.microsoft.com/office/drawing/2014/main" id="{70F8309C-832E-1138-7AA0-3DDACD61FF66}"/>
-              </a:ext>
-            </a:extLst>
-          </p:cNvPr>
-          <p:cNvSpPr>
-            <a:spLocks noGrp="1"/>
-          </p:cNvSpPr>
-          <p:nvPr>
-            <p:ph type="title"/>
-          </p:nvPr>
-        </p:nvSpPr>
-        <p:spPr/>
-        <p:txBody>
-          <a:bodyPr/>
-          <a:lstStyle/>
-          <a:p>
-            <a:r>
-              <a:rPr lang="en-US" dirty="0" err="1"/>
-              <a:t>Vertexer</a:t>
-            </a:r>
-            <a:r>
-              <a:rPr lang="en-US" dirty="0"/>
-              <a:t> Resolution</a:t>
-            </a:r>
-          </a:p>
-        </p:txBody>
-      </p:sp>
-      <p:sp>
-        <p:nvSpPr>
           <p:cNvPr id="3" name="Content Placeholder 2">
             <a:extLst>
               <a:ext uri="{FF2B5EF4-FFF2-40B4-BE49-F238E27FC236}">
@@ -11727,7 +11635,12 @@
             <p:ph idx="1"/>
           </p:nvPr>
         </p:nvSpPr>
-        <p:spPr/>
+        <p:spPr>
+          <a:xfrm>
+            <a:off x="0" y="424542"/>
+            <a:ext cx="12192000" cy="5931807"/>
+          </a:xfrm>
+        </p:spPr>
         <p:txBody>
           <a:bodyPr/>
           <a:lstStyle/>
@@ -12160,38 +12073,6 @@
       </p:grpSpPr>
       <p:sp>
         <p:nvSpPr>
-          <p:cNvPr id="2" name="Title 1">
-            <a:extLst>
-              <a:ext uri="{FF2B5EF4-FFF2-40B4-BE49-F238E27FC236}">
-                <a16:creationId xmlns:a16="http://schemas.microsoft.com/office/drawing/2014/main" id="{C359B161-21B7-E5E6-A68F-12F3880292B3}"/>
-              </a:ext>
-            </a:extLst>
-          </p:cNvPr>
-          <p:cNvSpPr>
-            <a:spLocks noGrp="1"/>
-          </p:cNvSpPr>
-          <p:nvPr>
-            <p:ph type="title"/>
-          </p:nvPr>
-        </p:nvSpPr>
-        <p:spPr/>
-        <p:txBody>
-          <a:bodyPr/>
-          <a:lstStyle/>
-          <a:p>
-            <a:r>
-              <a:rPr lang="en-US" dirty="0" err="1"/>
-              <a:t>Vertexer</a:t>
-            </a:r>
-            <a:r>
-              <a:rPr lang="en-US" dirty="0"/>
-              <a:t> Improvements</a:t>
-            </a:r>
-          </a:p>
-        </p:txBody>
-      </p:sp>
-      <p:sp>
-        <p:nvSpPr>
           <p:cNvPr id="3" name="Content Placeholder 2">
             <a:extLst>
               <a:ext uri="{FF2B5EF4-FFF2-40B4-BE49-F238E27FC236}">
@@ -12206,7 +12087,12 @@
             <p:ph idx="1"/>
           </p:nvPr>
         </p:nvSpPr>
-        <p:spPr/>
+        <p:spPr>
+          <a:xfrm>
+            <a:off x="0" y="424542"/>
+            <a:ext cx="12192000" cy="5931807"/>
+          </a:xfrm>
+        </p:spPr>
         <p:txBody>
           <a:bodyPr/>
           <a:lstStyle/>
@@ -12362,54 +12248,31 @@
       </p:grpSpPr>
       <p:sp>
         <p:nvSpPr>
-          <p:cNvPr id="2" name="Title 1">
-            <a:extLst>
-              <a:ext uri="{FF2B5EF4-FFF2-40B4-BE49-F238E27FC236}">
-                <a16:creationId xmlns:a16="http://schemas.microsoft.com/office/drawing/2014/main" id="{9FF94AB4-2094-057F-2C85-626AF64DE003}"/>
-              </a:ext>
-            </a:extLst>
-          </p:cNvPr>
-          <p:cNvSpPr>
-            <a:spLocks noGrp="1"/>
-          </p:cNvSpPr>
-          <p:nvPr>
-            <p:ph type="title"/>
-          </p:nvPr>
-        </p:nvSpPr>
-        <p:spPr/>
+          <p:cNvPr id="3" name="Content Placeholder 2">
+            <a:extLst>
+              <a:ext uri="{FF2B5EF4-FFF2-40B4-BE49-F238E27FC236}">
+                <a16:creationId xmlns:a16="http://schemas.microsoft.com/office/drawing/2014/main" id="{13699EC3-B19A-42E0-3396-2DD015FEE3E0}"/>
+              </a:ext>
+            </a:extLst>
+          </p:cNvPr>
+          <p:cNvSpPr>
+            <a:spLocks noGrp="1"/>
+          </p:cNvSpPr>
+          <p:nvPr>
+            <p:ph idx="1"/>
+          </p:nvPr>
+        </p:nvSpPr>
+        <p:spPr>
+          <a:xfrm>
+            <a:off x="0" y="551234"/>
+            <a:ext cx="12192000" cy="5805116"/>
+          </a:xfrm>
+        </p:spPr>
         <p:txBody>
           <a:bodyPr/>
           <a:lstStyle/>
           <a:p>
-            <a:r>
-              <a:rPr lang="en-US" dirty="0"/>
-              <a:t>Mixing of Relevant Backgrounds with Process</a:t>
-            </a:r>
-          </a:p>
-        </p:txBody>
-      </p:sp>
-      <p:sp>
-        <p:nvSpPr>
-          <p:cNvPr id="3" name="Content Placeholder 2">
-            <a:extLst>
-              <a:ext uri="{FF2B5EF4-FFF2-40B4-BE49-F238E27FC236}">
-                <a16:creationId xmlns:a16="http://schemas.microsoft.com/office/drawing/2014/main" id="{13699EC3-B19A-42E0-3396-2DD015FEE3E0}"/>
-              </a:ext>
-            </a:extLst>
-          </p:cNvPr>
-          <p:cNvSpPr>
-            <a:spLocks noGrp="1"/>
-          </p:cNvSpPr>
-          <p:nvPr>
-            <p:ph idx="1"/>
-          </p:nvPr>
-        </p:nvSpPr>
-        <p:spPr/>
-        <p:txBody>
-          <a:bodyPr/>
-          <a:lstStyle/>
-          <a:p>
-            <a:endParaRPr lang="en-US"/>
+            <a:endParaRPr lang="en-US" dirty="0"/>
           </a:p>
         </p:txBody>
       </p:sp>
@@ -12470,8 +12333,8 @@
           </a:p>
         </p:txBody>
       </p:sp>
-      <mc:AlternateContent xmlns:mc="http://schemas.openxmlformats.org/markup-compatibility/2006">
-        <mc:Choice xmlns:a14="http://schemas.microsoft.com/office/drawing/2010/main" Requires="a14">
+      <mc:AlternateContent xmlns:mc="http://schemas.openxmlformats.org/markup-compatibility/2006" xmlns:a14="http://schemas.microsoft.com/office/drawing/2010/main">
+        <mc:Choice Requires="a14">
           <p:sp>
             <p:nvSpPr>
               <p:cNvPr id="4" name="Title 1">
@@ -12537,6 +12400,7 @@
                               <a:srgbClr val="C00000"/>
                             </a:solidFill>
                             <a:latin typeface="Cambria Math" panose="02040503050406030204" pitchFamily="18" charset="0"/>
+                            <a:ea typeface="Cambria Math" panose="02040503050406030204" pitchFamily="18" charset="0"/>
                           </a:rPr>
                         </m:ctrlPr>
                       </m:sSupPr>
@@ -12567,7 +12431,7 @@
                     <m:sSup>
                       <m:sSupPr>
                         <m:ctrlPr>
-                          <a:rPr lang="en-US" sz="2800" i="1" smtClean="0">
+                          <a:rPr lang="en-US" sz="2800" b="0" i="1" smtClean="0">
                             <a:solidFill>
                               <a:srgbClr val="C00000"/>
                             </a:solidFill>
@@ -12611,7 +12475,7 @@
                     <m:sSup>
                       <m:sSupPr>
                         <m:ctrlPr>
-                          <a:rPr lang="en-US" sz="2800" i="1" smtClean="0">
+                          <a:rPr lang="en-US" sz="2800" b="0" i="1" smtClean="0">
                             <a:solidFill>
                               <a:srgbClr val="C00000"/>
                             </a:solidFill>
@@ -12648,7 +12512,7 @@
                     <m:sSup>
                       <m:sSupPr>
                         <m:ctrlPr>
-                          <a:rPr lang="en-US" sz="2800" i="1" smtClean="0">
+                          <a:rPr lang="en-US" sz="2800" b="0" i="1" smtClean="0">
                             <a:solidFill>
                               <a:srgbClr val="C00000"/>
                             </a:solidFill>
@@ -12696,7 +12560,7 @@
             </p:txBody>
           </p:sp>
         </mc:Choice>
-        <mc:Fallback>
+        <mc:Fallback xmlns="">
           <p:sp>
             <p:nvSpPr>
               <p:cNvPr id="4" name="Title 1">
@@ -12773,34 +12637,6 @@
       </p:grpSpPr>
       <p:sp>
         <p:nvSpPr>
-          <p:cNvPr id="2" name="Title 1">
-            <a:extLst>
-              <a:ext uri="{FF2B5EF4-FFF2-40B4-BE49-F238E27FC236}">
-                <a16:creationId xmlns:a16="http://schemas.microsoft.com/office/drawing/2014/main" id="{8637BF2B-5112-4B4D-10C3-5AF9705442AE}"/>
-              </a:ext>
-            </a:extLst>
-          </p:cNvPr>
-          <p:cNvSpPr>
-            <a:spLocks noGrp="1"/>
-          </p:cNvSpPr>
-          <p:nvPr>
-            <p:ph type="title"/>
-          </p:nvPr>
-        </p:nvSpPr>
-        <p:spPr/>
-        <p:txBody>
-          <a:bodyPr/>
-          <a:lstStyle/>
-          <a:p>
-            <a:r>
-              <a:rPr lang="en-US" dirty="0"/>
-              <a:t>Theoretical Refinement of Generator</a:t>
-            </a:r>
-          </a:p>
-        </p:txBody>
-      </p:sp>
-      <p:sp>
-        <p:nvSpPr>
           <p:cNvPr id="3" name="Content Placeholder 2">
             <a:extLst>
               <a:ext uri="{FF2B5EF4-FFF2-40B4-BE49-F238E27FC236}">
@@ -12815,7 +12651,12 @@
             <p:ph idx="1"/>
           </p:nvPr>
         </p:nvSpPr>
-        <p:spPr/>
+        <p:spPr>
+          <a:xfrm>
+            <a:off x="0" y="424542"/>
+            <a:ext cx="12192000" cy="5931807"/>
+          </a:xfrm>
+        </p:spPr>
         <p:txBody>
           <a:bodyPr/>
           <a:lstStyle/>
@@ -12969,59 +12810,66 @@
           <a:chExt cx="0" cy="0"/>
         </a:xfrm>
       </p:grpSpPr>
-      <p:sp>
-        <p:nvSpPr>
-          <p:cNvPr id="3" name="Content Placeholder 2">
-            <a:extLst>
-              <a:ext uri="{FF2B5EF4-FFF2-40B4-BE49-F238E27FC236}">
-                <a16:creationId xmlns:a16="http://schemas.microsoft.com/office/drawing/2014/main" id="{133185E4-2D81-D0B6-1538-D0309E1C74B5}"/>
-              </a:ext>
-            </a:extLst>
-          </p:cNvPr>
-          <p:cNvSpPr>
-            <a:spLocks noGrp="1"/>
-          </p:cNvSpPr>
+      <p:pic>
+        <p:nvPicPr>
+          <p:cNvPr id="4" name="Content Placeholder 3">
+            <a:extLst>
+              <a:ext uri="{FF2B5EF4-FFF2-40B4-BE49-F238E27FC236}">
+                <a16:creationId xmlns:a16="http://schemas.microsoft.com/office/drawing/2014/main" id="{26209EC7-1D2D-AD08-833B-AE136434F90D}"/>
+              </a:ext>
+            </a:extLst>
+          </p:cNvPr>
+          <p:cNvPicPr>
+            <a:picLocks noGrp="1" noChangeAspect="1"/>
+          </p:cNvPicPr>
           <p:nvPr>
             <p:ph idx="1"/>
           </p:nvPr>
-        </p:nvSpPr>
+        </p:nvPicPr>
+        <p:blipFill>
+          <a:blip r:embed="rId2"/>
+          <a:stretch>
+            <a:fillRect/>
+          </a:stretch>
+        </p:blipFill>
         <p:spPr>
           <a:xfrm>
-            <a:off x="0" y="424544"/>
-            <a:ext cx="12192000" cy="5752420"/>
+            <a:off x="-4549" y="424543"/>
+            <a:ext cx="6011989" cy="5753100"/>
+          </a:xfrm>
+          <a:prstGeom prst="rect">
+            <a:avLst/>
+          </a:prstGeom>
+        </p:spPr>
+      </p:pic>
+      <p:sp>
+        <p:nvSpPr>
+          <p:cNvPr id="5" name="Footer Placeholder 4">
+            <a:extLst>
+              <a:ext uri="{FF2B5EF4-FFF2-40B4-BE49-F238E27FC236}">
+                <a16:creationId xmlns:a16="http://schemas.microsoft.com/office/drawing/2014/main" id="{1F356C43-9187-1D95-38CE-90813B843A4F}"/>
+              </a:ext>
+            </a:extLst>
+          </p:cNvPr>
+          <p:cNvSpPr>
+            <a:spLocks noGrp="1"/>
+          </p:cNvSpPr>
+          <p:nvPr>
+            <p:ph type="ftr" sz="quarter" idx="11"/>
+          </p:nvPr>
+        </p:nvSpPr>
+        <p:spPr>
+          <a:xfrm>
+            <a:off x="4038600" y="6492875"/>
+            <a:ext cx="4114800" cy="365125"/>
           </a:xfrm>
         </p:spPr>
         <p:txBody>
           <a:bodyPr/>
           <a:lstStyle/>
           <a:p>
-            <a:endParaRPr lang="en-US" dirty="0"/>
-          </a:p>
-        </p:txBody>
-      </p:sp>
-      <p:sp>
-        <p:nvSpPr>
-          <p:cNvPr id="5" name="Footer Placeholder 4">
-            <a:extLst>
-              <a:ext uri="{FF2B5EF4-FFF2-40B4-BE49-F238E27FC236}">
-                <a16:creationId xmlns:a16="http://schemas.microsoft.com/office/drawing/2014/main" id="{1F356C43-9187-1D95-38CE-90813B843A4F}"/>
-              </a:ext>
-            </a:extLst>
-          </p:cNvPr>
-          <p:cNvSpPr>
-            <a:spLocks noGrp="1"/>
-          </p:cNvSpPr>
-          <p:nvPr>
-            <p:ph type="ftr" sz="quarter" idx="11"/>
-          </p:nvPr>
-        </p:nvSpPr>
-        <p:spPr/>
-        <p:txBody>
-          <a:bodyPr/>
-          <a:lstStyle/>
-          <a:p>
-            <a:r>
-              <a:rPr lang="en-US"/>
+            <a:r>
+              <a:rPr lang="en-US" dirty="0"/>
               <a:t>Boldy Sensitivity Study Mu2e</a:t>
             </a:r>
           </a:p>
@@ -13111,6 +12959,284 @@
               </a:rPr>
               <a:t>The Standard Model of Particle Physics</a:t>
             </a:r>
+          </a:p>
+        </p:txBody>
+      </p:sp>
+      <p:sp>
+        <p:nvSpPr>
+          <p:cNvPr id="7" name="TextBox 6">
+            <a:extLst>
+              <a:ext uri="{FF2B5EF4-FFF2-40B4-BE49-F238E27FC236}">
+                <a16:creationId xmlns:a16="http://schemas.microsoft.com/office/drawing/2014/main" id="{99905CEC-1FD0-51BE-F2D3-E8DE82709A78}"/>
+              </a:ext>
+            </a:extLst>
+          </p:cNvPr>
+          <p:cNvSpPr txBox="1"/>
+          <p:nvPr/>
+        </p:nvSpPr>
+        <p:spPr>
+          <a:xfrm>
+            <a:off x="6184562" y="212271"/>
+            <a:ext cx="5663821" cy="6740307"/>
+          </a:xfrm>
+          <a:prstGeom prst="rect">
+            <a:avLst/>
+          </a:prstGeom>
+          <a:noFill/>
+        </p:spPr>
+        <p:txBody>
+          <a:bodyPr wrap="square" rtlCol="0">
+            <a:spAutoFit/>
+          </a:bodyPr>
+          <a:lstStyle/>
+          <a:p>
+            <a:pPr marL="285750" indent="-285750">
+              <a:buFont typeface="Arial" panose="020B0604020202020204" pitchFamily="34" charset="0"/>
+              <a:buChar char="•"/>
+            </a:pPr>
+            <a:r>
+              <a:rPr lang="en-US" dirty="0"/>
+              <a:t>Matter Particles: fermions</a:t>
+            </a:r>
+          </a:p>
+          <a:p>
+            <a:pPr marL="742950" lvl="1" indent="-285750">
+              <a:buFont typeface="Arial" panose="020B0604020202020204" pitchFamily="34" charset="0"/>
+              <a:buChar char="•"/>
+            </a:pPr>
+            <a:r>
+              <a:rPr lang="en-US" dirty="0"/>
+              <a:t>Quarks (positively and negatively charged)</a:t>
+            </a:r>
+          </a:p>
+          <a:p>
+            <a:pPr marL="742950" lvl="1" indent="-285750">
+              <a:buFont typeface="Arial" panose="020B0604020202020204" pitchFamily="34" charset="0"/>
+              <a:buChar char="•"/>
+            </a:pPr>
+            <a:r>
+              <a:rPr lang="en-US" dirty="0"/>
+              <a:t>Leptons (charged and uncharged)</a:t>
+            </a:r>
+          </a:p>
+          <a:p>
+            <a:pPr marL="285750" indent="-285750">
+              <a:buFont typeface="Arial" panose="020B0604020202020204" pitchFamily="34" charset="0"/>
+              <a:buChar char="•"/>
+            </a:pPr>
+            <a:r>
+              <a:rPr lang="en-US" dirty="0"/>
+              <a:t>Interaction Particles: bosons</a:t>
+            </a:r>
+          </a:p>
+          <a:p>
+            <a:pPr marL="742950" lvl="1" indent="-285750">
+              <a:buFont typeface="Arial" panose="020B0604020202020204" pitchFamily="34" charset="0"/>
+              <a:buChar char="•"/>
+            </a:pPr>
+            <a:r>
+              <a:rPr lang="en-US" dirty="0"/>
+              <a:t>Gluons</a:t>
+            </a:r>
+          </a:p>
+          <a:p>
+            <a:pPr marL="742950" lvl="1" indent="-285750">
+              <a:buFont typeface="Arial" panose="020B0604020202020204" pitchFamily="34" charset="0"/>
+              <a:buChar char="•"/>
+            </a:pPr>
+            <a:r>
+              <a:rPr lang="en-US" dirty="0"/>
+              <a:t>Photon</a:t>
+            </a:r>
+          </a:p>
+          <a:p>
+            <a:pPr marL="742950" lvl="1" indent="-285750">
+              <a:buFont typeface="Arial" panose="020B0604020202020204" pitchFamily="34" charset="0"/>
+              <a:buChar char="•"/>
+            </a:pPr>
+            <a:r>
+              <a:rPr lang="en-US" dirty="0"/>
+              <a:t>Z boson</a:t>
+            </a:r>
+          </a:p>
+          <a:p>
+            <a:pPr marL="742950" lvl="1" indent="-285750">
+              <a:buFont typeface="Arial" panose="020B0604020202020204" pitchFamily="34" charset="0"/>
+              <a:buChar char="•"/>
+            </a:pPr>
+            <a:r>
+              <a:rPr lang="en-US" dirty="0"/>
+              <a:t>W bosons</a:t>
+            </a:r>
+          </a:p>
+          <a:p>
+            <a:pPr marL="285750" indent="-285750">
+              <a:buFont typeface="Arial" panose="020B0604020202020204" pitchFamily="34" charset="0"/>
+              <a:buChar char="•"/>
+            </a:pPr>
+            <a:r>
+              <a:rPr lang="en-US" dirty="0"/>
+              <a:t>Higgs Boson (responsible for masses)</a:t>
+            </a:r>
+          </a:p>
+          <a:p>
+            <a:endParaRPr lang="en-US" dirty="0"/>
+          </a:p>
+          <a:p>
+            <a:pPr marL="285750" indent="-285750">
+              <a:buFont typeface="Arial" panose="020B0604020202020204" pitchFamily="34" charset="0"/>
+              <a:buChar char="•"/>
+            </a:pPr>
+            <a:r>
+              <a:rPr lang="en-US" dirty="0"/>
+              <a:t>Matter particles have flavor (distinguishing quantum numbers)</a:t>
+            </a:r>
+          </a:p>
+          <a:p>
+            <a:pPr marL="742950" lvl="1" indent="-285750">
+              <a:buFont typeface="Arial" panose="020B0604020202020204" pitchFamily="34" charset="0"/>
+              <a:buChar char="•"/>
+            </a:pPr>
+            <a:r>
+              <a:rPr lang="en-US" dirty="0"/>
+              <a:t>Quark flavors: up, down, charm, strange, top, bottom </a:t>
+            </a:r>
+          </a:p>
+          <a:p>
+            <a:pPr marL="742950" lvl="1" indent="-285750">
+              <a:buFont typeface="Arial" panose="020B0604020202020204" pitchFamily="34" charset="0"/>
+              <a:buChar char="•"/>
+            </a:pPr>
+            <a:r>
+              <a:rPr lang="en-US" dirty="0"/>
+              <a:t>Charged Lepton flavors: electron, muon, tau</a:t>
+            </a:r>
+          </a:p>
+          <a:p>
+            <a:pPr marL="742950" lvl="1" indent="-285750">
+              <a:buFont typeface="Arial" panose="020B0604020202020204" pitchFamily="34" charset="0"/>
+              <a:buChar char="•"/>
+            </a:pPr>
+            <a:r>
+              <a:rPr lang="en-US" dirty="0"/>
+              <a:t>Uncharged Lepton flavors: electron neutrino, muon neutrino, tau neutrino</a:t>
+            </a:r>
+          </a:p>
+          <a:p>
+            <a:pPr marL="742950" lvl="1" indent="-285750">
+              <a:buFont typeface="Arial" panose="020B0604020202020204" pitchFamily="34" charset="0"/>
+              <a:buChar char="•"/>
+            </a:pPr>
+            <a:endParaRPr lang="en-US" dirty="0"/>
+          </a:p>
+          <a:p>
+            <a:pPr marL="285750" indent="-285750">
+              <a:buFont typeface="Arial" panose="020B0604020202020204" pitchFamily="34" charset="0"/>
+              <a:buChar char="•"/>
+            </a:pPr>
+            <a:r>
+              <a:rPr lang="en-US" dirty="0"/>
+              <a:t>Fundamental symmetries of Standard Model: gauge group symmetries</a:t>
+            </a:r>
+          </a:p>
+          <a:p>
+            <a:pPr marL="285750" indent="-285750">
+              <a:buFont typeface="Arial" panose="020B0604020202020204" pitchFamily="34" charset="0"/>
+              <a:buChar char="•"/>
+            </a:pPr>
+            <a:r>
+              <a:rPr lang="en-US" dirty="0"/>
+              <a:t>Boson number, lepton number, and lepton flavor number considered to be “accidental” symmetry not required by the fundamental group structure </a:t>
+            </a:r>
+          </a:p>
+          <a:p>
+            <a:pPr marL="742950" lvl="1" indent="-285750">
+              <a:buFont typeface="Arial" panose="020B0604020202020204" pitchFamily="34" charset="0"/>
+              <a:buChar char="•"/>
+            </a:pPr>
+            <a:endParaRPr lang="en-US" dirty="0"/>
+          </a:p>
+        </p:txBody>
+      </p:sp>
+      <p:pic>
+        <p:nvPicPr>
+          <p:cNvPr id="9" name="Picture 8">
+            <a:extLst>
+              <a:ext uri="{FF2B5EF4-FFF2-40B4-BE49-F238E27FC236}">
+                <a16:creationId xmlns:a16="http://schemas.microsoft.com/office/drawing/2014/main" id="{4F0340E1-21BE-68F7-BEDB-0DBFC95C15E2}"/>
+              </a:ext>
+            </a:extLst>
+          </p:cNvPr>
+          <p:cNvPicPr>
+            <a:picLocks noChangeAspect="1"/>
+          </p:cNvPicPr>
+          <p:nvPr/>
+        </p:nvPicPr>
+        <p:blipFill>
+          <a:blip r:embed="rId3"/>
+          <a:stretch>
+            <a:fillRect/>
+          </a:stretch>
+        </p:blipFill>
+        <p:spPr>
+          <a:xfrm>
+            <a:off x="8455253" y="5498481"/>
+            <a:ext cx="3570252" cy="229948"/>
+          </a:xfrm>
+          <a:prstGeom prst="rect">
+            <a:avLst/>
+          </a:prstGeom>
+        </p:spPr>
+      </p:pic>
+      <p:sp>
+        <p:nvSpPr>
+          <p:cNvPr id="10" name="Rectangle 9">
+            <a:extLst>
+              <a:ext uri="{FF2B5EF4-FFF2-40B4-BE49-F238E27FC236}">
+                <a16:creationId xmlns:a16="http://schemas.microsoft.com/office/drawing/2014/main" id="{63566328-0143-B62C-994C-4478F1C47740}"/>
+              </a:ext>
+            </a:extLst>
+          </p:cNvPr>
+          <p:cNvSpPr/>
+          <p:nvPr/>
+        </p:nvSpPr>
+        <p:spPr>
+          <a:xfrm>
+            <a:off x="327546" y="3766782"/>
+            <a:ext cx="3384645" cy="1173708"/>
+          </a:xfrm>
+          <a:prstGeom prst="rect">
+            <a:avLst/>
+          </a:prstGeom>
+          <a:noFill/>
+          <a:ln w="88900">
+            <a:solidFill>
+              <a:srgbClr val="FF0000"/>
+            </a:solidFill>
+          </a:ln>
+        </p:spPr>
+        <p:style>
+          <a:lnRef idx="2">
+            <a:schemeClr val="accent1">
+              <a:shade val="15000"/>
+            </a:schemeClr>
+          </a:lnRef>
+          <a:fillRef idx="1">
+            <a:schemeClr val="accent1"/>
+          </a:fillRef>
+          <a:effectRef idx="0">
+            <a:schemeClr val="accent1"/>
+          </a:effectRef>
+          <a:fontRef idx="minor">
+            <a:schemeClr val="lt1"/>
+          </a:fontRef>
+        </p:style>
+        <p:txBody>
+          <a:bodyPr rtlCol="0" anchor="ctr"/>
+          <a:lstStyle/>
+          <a:p>
+            <a:pPr algn="ctr"/>
+            <a:endParaRPr lang="en-US"/>
           </a:p>
         </p:txBody>
       </p:sp>
@@ -13146,34 +13272,6 @@
       </p:grpSpPr>
       <p:sp>
         <p:nvSpPr>
-          <p:cNvPr id="2" name="Title 1">
-            <a:extLst>
-              <a:ext uri="{FF2B5EF4-FFF2-40B4-BE49-F238E27FC236}">
-                <a16:creationId xmlns:a16="http://schemas.microsoft.com/office/drawing/2014/main" id="{CF447FA9-7EA7-7F99-9C52-F7F52DA585CD}"/>
-              </a:ext>
-            </a:extLst>
-          </p:cNvPr>
-          <p:cNvSpPr>
-            <a:spLocks noGrp="1"/>
-          </p:cNvSpPr>
-          <p:nvPr>
-            <p:ph type="title"/>
-          </p:nvPr>
-        </p:nvSpPr>
-        <p:spPr/>
-        <p:txBody>
-          <a:bodyPr/>
-          <a:lstStyle/>
-          <a:p>
-            <a:r>
-              <a:rPr lang="en-US" dirty="0"/>
-              <a:t>Full Sensitivity Study and Statistical Analysis</a:t>
-            </a:r>
-          </a:p>
-        </p:txBody>
-      </p:sp>
-      <p:sp>
-        <p:nvSpPr>
           <p:cNvPr id="3" name="Content Placeholder 2">
             <a:extLst>
               <a:ext uri="{FF2B5EF4-FFF2-40B4-BE49-F238E27FC236}">
@@ -13188,7 +13286,12 @@
             <p:ph idx="1"/>
           </p:nvPr>
         </p:nvSpPr>
-        <p:spPr/>
+        <p:spPr>
+          <a:xfrm>
+            <a:off x="0" y="424542"/>
+            <a:ext cx="12192000" cy="5931807"/>
+          </a:xfrm>
+        </p:spPr>
         <p:txBody>
           <a:bodyPr/>
           <a:lstStyle/>
@@ -13344,54 +13447,31 @@
       </p:grpSpPr>
       <p:sp>
         <p:nvSpPr>
-          <p:cNvPr id="2" name="Title 1">
-            <a:extLst>
-              <a:ext uri="{FF2B5EF4-FFF2-40B4-BE49-F238E27FC236}">
-                <a16:creationId xmlns:a16="http://schemas.microsoft.com/office/drawing/2014/main" id="{939D62CE-5A2C-7C21-97D4-D629099398DD}"/>
-              </a:ext>
-            </a:extLst>
-          </p:cNvPr>
-          <p:cNvSpPr>
-            <a:spLocks noGrp="1"/>
-          </p:cNvSpPr>
-          <p:nvPr>
-            <p:ph type="title"/>
-          </p:nvPr>
-        </p:nvSpPr>
-        <p:spPr/>
+          <p:cNvPr id="3" name="Content Placeholder 2">
+            <a:extLst>
+              <a:ext uri="{FF2B5EF4-FFF2-40B4-BE49-F238E27FC236}">
+                <a16:creationId xmlns:a16="http://schemas.microsoft.com/office/drawing/2014/main" id="{618C2519-85BE-4DAD-8C77-85B9CC8DE9BC}"/>
+              </a:ext>
+            </a:extLst>
+          </p:cNvPr>
+          <p:cNvSpPr>
+            <a:spLocks noGrp="1"/>
+          </p:cNvSpPr>
+          <p:nvPr>
+            <p:ph idx="1"/>
+          </p:nvPr>
+        </p:nvSpPr>
+        <p:spPr>
+          <a:xfrm>
+            <a:off x="0" y="424542"/>
+            <a:ext cx="12192000" cy="5931807"/>
+          </a:xfrm>
+        </p:spPr>
         <p:txBody>
           <a:bodyPr/>
           <a:lstStyle/>
           <a:p>
-            <a:r>
-              <a:rPr lang="en-US" dirty="0"/>
-              <a:t>Additional Approaches to Improve Argument</a:t>
-            </a:r>
-          </a:p>
-        </p:txBody>
-      </p:sp>
-      <p:sp>
-        <p:nvSpPr>
-          <p:cNvPr id="3" name="Content Placeholder 2">
-            <a:extLst>
-              <a:ext uri="{FF2B5EF4-FFF2-40B4-BE49-F238E27FC236}">
-                <a16:creationId xmlns:a16="http://schemas.microsoft.com/office/drawing/2014/main" id="{618C2519-85BE-4DAD-8C77-85B9CC8DE9BC}"/>
-              </a:ext>
-            </a:extLst>
-          </p:cNvPr>
-          <p:cNvSpPr>
-            <a:spLocks noGrp="1"/>
-          </p:cNvSpPr>
-          <p:nvPr>
-            <p:ph idx="1"/>
-          </p:nvPr>
-        </p:nvSpPr>
-        <p:spPr/>
-        <p:txBody>
-          <a:bodyPr/>
-          <a:lstStyle/>
-          <a:p>
-            <a:endParaRPr lang="en-US"/>
+            <a:endParaRPr lang="en-US" dirty="0"/>
           </a:p>
         </p:txBody>
       </p:sp>
@@ -13542,54 +13622,31 @@
       </p:grpSpPr>
       <p:sp>
         <p:nvSpPr>
-          <p:cNvPr id="2" name="Title 1">
-            <a:extLst>
-              <a:ext uri="{FF2B5EF4-FFF2-40B4-BE49-F238E27FC236}">
-                <a16:creationId xmlns:a16="http://schemas.microsoft.com/office/drawing/2014/main" id="{BC8DCCEE-F6E7-0A1C-8C4B-C538663A3DE9}"/>
-              </a:ext>
-            </a:extLst>
-          </p:cNvPr>
-          <p:cNvSpPr>
-            <a:spLocks noGrp="1"/>
-          </p:cNvSpPr>
-          <p:nvPr>
-            <p:ph type="title"/>
-          </p:nvPr>
-        </p:nvSpPr>
-        <p:spPr/>
+          <p:cNvPr id="3" name="Content Placeholder 2">
+            <a:extLst>
+              <a:ext uri="{FF2B5EF4-FFF2-40B4-BE49-F238E27FC236}">
+                <a16:creationId xmlns:a16="http://schemas.microsoft.com/office/drawing/2014/main" id="{5D0FB4EB-5C21-B80A-9106-2C474B5D434C}"/>
+              </a:ext>
+            </a:extLst>
+          </p:cNvPr>
+          <p:cNvSpPr>
+            <a:spLocks noGrp="1"/>
+          </p:cNvSpPr>
+          <p:nvPr>
+            <p:ph idx="1"/>
+          </p:nvPr>
+        </p:nvSpPr>
+        <p:spPr>
+          <a:xfrm>
+            <a:off x="0" y="424542"/>
+            <a:ext cx="12192000" cy="5931807"/>
+          </a:xfrm>
+        </p:spPr>
         <p:txBody>
           <a:bodyPr/>
           <a:lstStyle/>
           <a:p>
-            <a:r>
-              <a:rPr lang="en-US" dirty="0"/>
-              <a:t>Additional Professional Development</a:t>
-            </a:r>
-          </a:p>
-        </p:txBody>
-      </p:sp>
-      <p:sp>
-        <p:nvSpPr>
-          <p:cNvPr id="3" name="Content Placeholder 2">
-            <a:extLst>
-              <a:ext uri="{FF2B5EF4-FFF2-40B4-BE49-F238E27FC236}">
-                <a16:creationId xmlns:a16="http://schemas.microsoft.com/office/drawing/2014/main" id="{5D0FB4EB-5C21-B80A-9106-2C474B5D434C}"/>
-              </a:ext>
-            </a:extLst>
-          </p:cNvPr>
-          <p:cNvSpPr>
-            <a:spLocks noGrp="1"/>
-          </p:cNvSpPr>
-          <p:nvPr>
-            <p:ph idx="1"/>
-          </p:nvPr>
-        </p:nvSpPr>
-        <p:spPr/>
-        <p:txBody>
-          <a:bodyPr/>
-          <a:lstStyle/>
-          <a:p>
-            <a:endParaRPr lang="en-US"/>
+            <a:endParaRPr lang="en-US" dirty="0"/>
           </a:p>
         </p:txBody>
       </p:sp>
@@ -13740,54 +13797,31 @@
       </p:grpSpPr>
       <p:sp>
         <p:nvSpPr>
-          <p:cNvPr id="2" name="Title 1">
-            <a:extLst>
-              <a:ext uri="{FF2B5EF4-FFF2-40B4-BE49-F238E27FC236}">
-                <a16:creationId xmlns:a16="http://schemas.microsoft.com/office/drawing/2014/main" id="{3AF9D99B-40BF-62FD-3259-626DC28F1232}"/>
-              </a:ext>
-            </a:extLst>
-          </p:cNvPr>
-          <p:cNvSpPr>
-            <a:spLocks noGrp="1"/>
-          </p:cNvSpPr>
-          <p:nvPr>
-            <p:ph type="title"/>
-          </p:nvPr>
-        </p:nvSpPr>
-        <p:spPr/>
+          <p:cNvPr id="3" name="Content Placeholder 2">
+            <a:extLst>
+              <a:ext uri="{FF2B5EF4-FFF2-40B4-BE49-F238E27FC236}">
+                <a16:creationId xmlns:a16="http://schemas.microsoft.com/office/drawing/2014/main" id="{A7650A4E-F4CA-5280-6975-74FBD5529A02}"/>
+              </a:ext>
+            </a:extLst>
+          </p:cNvPr>
+          <p:cNvSpPr>
+            <a:spLocks noGrp="1"/>
+          </p:cNvSpPr>
+          <p:nvPr>
+            <p:ph idx="1"/>
+          </p:nvPr>
+        </p:nvSpPr>
+        <p:spPr>
+          <a:xfrm>
+            <a:off x="0" y="424542"/>
+            <a:ext cx="12192000" cy="5931807"/>
+          </a:xfrm>
+        </p:spPr>
         <p:txBody>
           <a:bodyPr/>
           <a:lstStyle/>
           <a:p>
-            <a:r>
-              <a:rPr lang="en-US" dirty="0"/>
-              <a:t>Summary</a:t>
-            </a:r>
-          </a:p>
-        </p:txBody>
-      </p:sp>
-      <p:sp>
-        <p:nvSpPr>
-          <p:cNvPr id="3" name="Content Placeholder 2">
-            <a:extLst>
-              <a:ext uri="{FF2B5EF4-FFF2-40B4-BE49-F238E27FC236}">
-                <a16:creationId xmlns:a16="http://schemas.microsoft.com/office/drawing/2014/main" id="{A7650A4E-F4CA-5280-6975-74FBD5529A02}"/>
-              </a:ext>
-            </a:extLst>
-          </p:cNvPr>
-          <p:cNvSpPr>
-            <a:spLocks noGrp="1"/>
-          </p:cNvSpPr>
-          <p:nvPr>
-            <p:ph idx="1"/>
-          </p:nvPr>
-        </p:nvSpPr>
-        <p:spPr/>
-        <p:txBody>
-          <a:bodyPr/>
-          <a:lstStyle/>
-          <a:p>
-            <a:endParaRPr lang="en-US"/>
+            <a:endParaRPr lang="en-US" dirty="0"/>
           </a:p>
         </p:txBody>
       </p:sp>
@@ -14651,8 +14685,8 @@
           </a:p>
         </p:txBody>
       </p:sp>
-      <mc:AlternateContent xmlns:mc="http://schemas.openxmlformats.org/markup-compatibility/2006" xmlns:a14="http://schemas.microsoft.com/office/drawing/2010/main">
-        <mc:Choice Requires="a14">
+      <mc:AlternateContent xmlns:mc="http://schemas.openxmlformats.org/markup-compatibility/2006">
+        <mc:Choice xmlns:a14="http://schemas.microsoft.com/office/drawing/2010/main" Requires="a14">
           <p:sp>
             <p:nvSpPr>
               <p:cNvPr id="3" name="Content Placeholder 2">
@@ -14677,7 +14711,7 @@
             </p:spPr>
             <p:txBody>
               <a:bodyPr>
-                <a:normAutofit lnSpcReduction="10000"/>
+                <a:normAutofit fontScale="92500" lnSpcReduction="10000"/>
               </a:bodyPr>
               <a:lstStyle/>
               <a:p>
@@ -14800,6 +14834,9 @@
                 <a:endParaRPr lang="en-US" dirty="0"/>
               </a:p>
               <a:p>
+                <a:endParaRPr lang="en-US" dirty="0"/>
+              </a:p>
+              <a:p>
                 <a:pPr marL="0" indent="0">
                   <a:buNone/>
                 </a:pPr>
@@ -14820,22 +14857,8 @@
                 </a14:m>
                 <a:r>
                   <a:rPr lang="en-US" dirty="0"/>
-                  <a:t>) is comprised of multiple different efficiencies </a:t>
+                  <a:t>) is comprised of multiple different efficiencies multiplied together: 						           found via simulation</a:t>
                 </a:r>
-                <a:r>
-                  <a:rPr lang="en-US" dirty="0" err="1"/>
-                  <a:t>multipled</a:t>
-                </a:r>
-                <a:r>
-                  <a:rPr lang="en-US" dirty="0"/>
-                  <a:t> together: 						           found via simulation</a:t>
-                </a:r>
-              </a:p>
-              <a:p>
-                <a:pPr marL="0" indent="0">
-                  <a:buNone/>
-                </a:pPr>
-                <a:endParaRPr lang="en-US" dirty="0"/>
               </a:p>
               <a:p>
                 <a:pPr marL="0" indent="0">
@@ -14846,7 +14869,7 @@
             </p:txBody>
           </p:sp>
         </mc:Choice>
-        <mc:Fallback xmlns="">
+        <mc:Fallback>
           <p:sp>
             <p:nvSpPr>
               <p:cNvPr id="3" name="Content Placeholder 2">
@@ -14871,7 +14894,7 @@
               <a:blipFill>
                 <a:blip r:embed="rId2"/>
                 <a:stretch>
-                  <a:fillRect l="-1145" t="-2326" r="-1249" b="-423"/>
+                  <a:fillRect l="-937" t="-1903" b="-1903"/>
                 </a:stretch>
               </a:blipFill>
             </p:spPr>
@@ -15029,7 +15052,7 @@
         </p:blipFill>
         <p:spPr>
           <a:xfrm>
-            <a:off x="2235925" y="3311660"/>
+            <a:off x="2405742" y="3174009"/>
             <a:ext cx="6043748" cy="706871"/>
           </a:xfrm>
           <a:prstGeom prst="rect">
@@ -15089,7 +15112,7 @@
         </p:blipFill>
         <p:spPr>
           <a:xfrm>
-            <a:off x="1577543" y="5960987"/>
+            <a:off x="1482009" y="6061800"/>
             <a:ext cx="5622267" cy="201626"/>
           </a:xfrm>
           <a:prstGeom prst="rect">
@@ -15127,43 +15150,666 @@
           <a:chExt cx="0" cy="0"/>
         </a:xfrm>
       </p:grpSpPr>
-      <p:sp>
-        <p:nvSpPr>
-          <p:cNvPr id="3" name="Content Placeholder 2">
-            <a:extLst>
-              <a:ext uri="{FF2B5EF4-FFF2-40B4-BE49-F238E27FC236}">
-                <a16:creationId xmlns:a16="http://schemas.microsoft.com/office/drawing/2014/main" id="{5F9290EE-BEC6-0A6E-2D4B-BA3D8AFA5182}"/>
-              </a:ext>
-            </a:extLst>
-          </p:cNvPr>
-          <p:cNvSpPr>
-            <a:spLocks noGrp="1"/>
-          </p:cNvSpPr>
-          <p:nvPr>
-            <p:ph idx="1"/>
-          </p:nvPr>
-        </p:nvSpPr>
-        <p:spPr>
-          <a:xfrm>
-            <a:off x="0" y="574765"/>
-            <a:ext cx="12192000" cy="5602197"/>
-          </a:xfrm>
-        </p:spPr>
-        <p:txBody>
-          <a:bodyPr/>
-          <a:lstStyle/>
-          <a:p>
-            <a:r>
-              <a:rPr lang="en-US" dirty="0"/>
-              <a:t>Values to use in the calculation:</a:t>
-            </a:r>
-          </a:p>
-          <a:p>
-            <a:pPr lvl="1"/>
-            <a:endParaRPr lang="en-US" dirty="0"/>
-          </a:p>
-        </p:txBody>
-      </p:sp>
+      <mc:AlternateContent xmlns:mc="http://schemas.openxmlformats.org/markup-compatibility/2006">
+        <mc:Choice xmlns:a14="http://schemas.microsoft.com/office/drawing/2010/main" Requires="a14">
+          <p:sp>
+            <p:nvSpPr>
+              <p:cNvPr id="3" name="Content Placeholder 2">
+                <a:extLst>
+                  <a:ext uri="{FF2B5EF4-FFF2-40B4-BE49-F238E27FC236}">
+                    <a16:creationId xmlns:a16="http://schemas.microsoft.com/office/drawing/2014/main" id="{5F9290EE-BEC6-0A6E-2D4B-BA3D8AFA5182}"/>
+                  </a:ext>
+                </a:extLst>
+              </p:cNvPr>
+              <p:cNvSpPr>
+                <a:spLocks noGrp="1"/>
+              </p:cNvSpPr>
+              <p:nvPr>
+                <p:ph idx="1"/>
+              </p:nvPr>
+            </p:nvSpPr>
+            <p:spPr>
+              <a:xfrm>
+                <a:off x="0" y="574765"/>
+                <a:ext cx="12192000" cy="5781585"/>
+              </a:xfrm>
+            </p:spPr>
+            <p:txBody>
+              <a:bodyPr>
+                <a:normAutofit/>
+              </a:bodyPr>
+              <a:lstStyle/>
+              <a:p>
+                <a:r>
+                  <a:rPr lang="en-US" dirty="0"/>
+                  <a:t>Values to use in the calculation: </a:t>
+                </a:r>
+              </a:p>
+              <a:p>
+                <a:pPr lvl="1"/>
+                <a14:m>
+                  <m:oMath xmlns:m="http://schemas.openxmlformats.org/officeDocument/2006/math">
+                    <m:r>
+                      <a:rPr lang="en-US" b="0" i="1" smtClean="0">
+                        <a:latin typeface="Cambria Math" panose="02040503050406030204" pitchFamily="18" charset="0"/>
+                      </a:rPr>
+                      <m:t>𝑃</m:t>
+                    </m:r>
+                    <m:r>
+                      <a:rPr lang="en-US" b="0" i="1" smtClean="0">
+                        <a:latin typeface="Cambria Math" panose="02040503050406030204" pitchFamily="18" charset="0"/>
+                      </a:rPr>
+                      <m:t>=1.5</m:t>
+                    </m:r>
+                  </m:oMath>
+                </a14:m>
+                <a:r>
+                  <a:rPr lang="en-US" dirty="0"/>
+                  <a:t> kW (Bernstein, 2019 Frontiers), needs to be reduced by large factor (300) for pileup considerations in reconstruction </a:t>
+                </a:r>
+                <a:r>
+                  <a:rPr lang="en-US" dirty="0">
+                    <a:sym typeface="Wingdings" pitchFamily="2" charset="2"/>
+                  </a:rPr>
+                  <a:t> exact to be determined</a:t>
+                </a:r>
+                <a:endParaRPr lang="en-US" dirty="0"/>
+              </a:p>
+              <a:p>
+                <a:pPr lvl="1"/>
+                <a14:m>
+                  <m:oMath xmlns:m="http://schemas.openxmlformats.org/officeDocument/2006/math">
+                    <m:sSub>
+                      <m:sSubPr>
+                        <m:ctrlPr>
+                          <a:rPr lang="en-US" b="0" i="1" smtClean="0">
+                            <a:latin typeface="Cambria Math" panose="02040503050406030204" pitchFamily="18" charset="0"/>
+                          </a:rPr>
+                        </m:ctrlPr>
+                      </m:sSubPr>
+                      <m:e>
+                        <m:r>
+                          <a:rPr lang="en-US" b="0" i="1" smtClean="0">
+                            <a:latin typeface="Cambria Math" panose="02040503050406030204" pitchFamily="18" charset="0"/>
+                          </a:rPr>
+                          <m:t>𝐸</m:t>
+                        </m:r>
+                      </m:e>
+                      <m:sub>
+                        <m:r>
+                          <a:rPr lang="en-US" b="0" i="1" smtClean="0">
+                            <a:latin typeface="Cambria Math" panose="02040503050406030204" pitchFamily="18" charset="0"/>
+                          </a:rPr>
+                          <m:t>𝑝</m:t>
+                        </m:r>
+                      </m:sub>
+                    </m:sSub>
+                    <m:r>
+                      <a:rPr lang="en-US" b="0" i="1" smtClean="0">
+                        <a:latin typeface="Cambria Math" panose="02040503050406030204" pitchFamily="18" charset="0"/>
+                      </a:rPr>
+                      <m:t>=8</m:t>
+                    </m:r>
+                  </m:oMath>
+                </a14:m>
+                <a:r>
+                  <a:rPr lang="en-US" dirty="0"/>
+                  <a:t> GeV</a:t>
+                </a:r>
+              </a:p>
+              <a:p>
+                <a:pPr lvl="1"/>
+                <a14:m>
+                  <m:oMath xmlns:m="http://schemas.openxmlformats.org/officeDocument/2006/math">
+                    <m:sSub>
+                      <m:sSubPr>
+                        <m:ctrlPr>
+                          <a:rPr lang="en-US" b="0" i="1" smtClean="0">
+                            <a:latin typeface="Cambria Math" panose="02040503050406030204" pitchFamily="18" charset="0"/>
+                          </a:rPr>
+                        </m:ctrlPr>
+                      </m:sSubPr>
+                      <m:e>
+                        <m:r>
+                          <a:rPr lang="en-US" b="0" i="1" smtClean="0">
+                            <a:latin typeface="Cambria Math" panose="02040503050406030204" pitchFamily="18" charset="0"/>
+                          </a:rPr>
+                          <m:t>𝑁</m:t>
+                        </m:r>
+                      </m:e>
+                      <m:sub>
+                        <m:r>
+                          <a:rPr lang="en-US" b="0" i="1" smtClean="0">
+                            <a:latin typeface="Cambria Math" panose="02040503050406030204" pitchFamily="18" charset="0"/>
+                          </a:rPr>
+                          <m:t>𝑠𝑡𝑜𝑝𝑠</m:t>
+                        </m:r>
+                      </m:sub>
+                    </m:sSub>
+                    <m:r>
+                      <a:rPr lang="en-US" b="0" i="1" smtClean="0">
+                        <a:latin typeface="Cambria Math" panose="02040503050406030204" pitchFamily="18" charset="0"/>
+                      </a:rPr>
+                      <m:t>=</m:t>
+                    </m:r>
+                    <m:sSup>
+                      <m:sSupPr>
+                        <m:ctrlPr>
+                          <a:rPr lang="en-US" b="0" i="1" smtClean="0">
+                            <a:latin typeface="Cambria Math" panose="02040503050406030204" pitchFamily="18" charset="0"/>
+                          </a:rPr>
+                        </m:ctrlPr>
+                      </m:sSupPr>
+                      <m:e>
+                        <m:r>
+                          <a:rPr lang="en-US" b="0" i="1" smtClean="0">
+                            <a:latin typeface="Cambria Math" panose="02040503050406030204" pitchFamily="18" charset="0"/>
+                          </a:rPr>
+                          <m:t>10</m:t>
+                        </m:r>
+                      </m:e>
+                      <m:sup>
+                        <m:r>
+                          <a:rPr lang="en-US" b="0" i="1" smtClean="0">
+                            <a:latin typeface="Cambria Math" panose="02040503050406030204" pitchFamily="18" charset="0"/>
+                          </a:rPr>
+                          <m:t>18</m:t>
+                        </m:r>
+                      </m:sup>
+                    </m:sSup>
+                    <m:r>
+                      <a:rPr lang="en-US" b="0" i="1" smtClean="0">
+                        <a:latin typeface="Cambria Math" panose="02040503050406030204" pitchFamily="18" charset="0"/>
+                      </a:rPr>
+                      <m:t> </m:t>
+                    </m:r>
+                    <m:r>
+                      <a:rPr lang="en-US" b="0" i="1" smtClean="0">
+                        <a:latin typeface="Cambria Math" panose="02040503050406030204" pitchFamily="18" charset="0"/>
+                        <a:ea typeface="Cambria Math" panose="02040503050406030204" pitchFamily="18" charset="0"/>
+                      </a:rPr>
+                      <m:t>𝜇</m:t>
+                    </m:r>
+                  </m:oMath>
+                </a14:m>
+                <a:endParaRPr lang="en-US" dirty="0"/>
+              </a:p>
+              <a:p>
+                <a:pPr lvl="1"/>
+                <a14:m>
+                  <m:oMath xmlns:m="http://schemas.openxmlformats.org/officeDocument/2006/math">
+                    <m:sSub>
+                      <m:sSubPr>
+                        <m:ctrlPr>
+                          <a:rPr lang="en-US" b="0" i="1" smtClean="0">
+                            <a:latin typeface="Cambria Math" panose="02040503050406030204" pitchFamily="18" charset="0"/>
+                          </a:rPr>
+                        </m:ctrlPr>
+                      </m:sSubPr>
+                      <m:e>
+                        <m:r>
+                          <a:rPr lang="en-US" b="0" i="1" smtClean="0">
+                            <a:latin typeface="Cambria Math" panose="02040503050406030204" pitchFamily="18" charset="0"/>
+                          </a:rPr>
+                          <m:t>𝑁</m:t>
+                        </m:r>
+                      </m:e>
+                      <m:sub>
+                        <m:r>
+                          <a:rPr lang="en-US" b="0" i="1" smtClean="0">
+                            <a:latin typeface="Cambria Math" panose="02040503050406030204" pitchFamily="18" charset="0"/>
+                          </a:rPr>
+                          <m:t>𝑃𝑂𝑇</m:t>
+                        </m:r>
+                      </m:sub>
+                    </m:sSub>
+                    <m:r>
+                      <a:rPr lang="en-US" b="0" i="1" smtClean="0">
+                        <a:latin typeface="Cambria Math" panose="02040503050406030204" pitchFamily="18" charset="0"/>
+                      </a:rPr>
+                      <m:t>=3.8</m:t>
+                    </m:r>
+                    <m:r>
+                      <a:rPr lang="en-US" b="0" i="1" smtClean="0">
+                        <a:latin typeface="Cambria Math" panose="02040503050406030204" pitchFamily="18" charset="0"/>
+                        <a:ea typeface="Cambria Math" panose="02040503050406030204" pitchFamily="18" charset="0"/>
+                      </a:rPr>
+                      <m:t>×</m:t>
+                    </m:r>
+                    <m:sSup>
+                      <m:sSupPr>
+                        <m:ctrlPr>
+                          <a:rPr lang="en-US" b="0" i="1" smtClean="0">
+                            <a:latin typeface="Cambria Math" panose="02040503050406030204" pitchFamily="18" charset="0"/>
+                            <a:ea typeface="Cambria Math" panose="02040503050406030204" pitchFamily="18" charset="0"/>
+                          </a:rPr>
+                        </m:ctrlPr>
+                      </m:sSupPr>
+                      <m:e>
+                        <m:r>
+                          <a:rPr lang="en-US" b="0" i="1" smtClean="0">
+                            <a:latin typeface="Cambria Math" panose="02040503050406030204" pitchFamily="18" charset="0"/>
+                            <a:ea typeface="Cambria Math" panose="02040503050406030204" pitchFamily="18" charset="0"/>
+                          </a:rPr>
+                          <m:t>10</m:t>
+                        </m:r>
+                      </m:e>
+                      <m:sup>
+                        <m:r>
+                          <a:rPr lang="en-US" b="0" i="1" smtClean="0">
+                            <a:latin typeface="Cambria Math" panose="02040503050406030204" pitchFamily="18" charset="0"/>
+                            <a:ea typeface="Cambria Math" panose="02040503050406030204" pitchFamily="18" charset="0"/>
+                          </a:rPr>
+                          <m:t>20</m:t>
+                        </m:r>
+                      </m:sup>
+                    </m:sSup>
+                  </m:oMath>
+                </a14:m>
+                <a:r>
+                  <a:rPr lang="en-US" dirty="0"/>
+                  <a:t> protons</a:t>
+                </a:r>
+              </a:p>
+              <a:p>
+                <a:pPr lvl="1"/>
+                <a14:m>
+                  <m:oMath xmlns:m="http://schemas.openxmlformats.org/officeDocument/2006/math">
+                    <m:r>
+                      <a:rPr lang="en-US" b="0" i="1" smtClean="0">
+                        <a:latin typeface="Cambria Math" panose="02040503050406030204" pitchFamily="18" charset="0"/>
+                      </a:rPr>
+                      <m:t>𝐵𝑟</m:t>
+                    </m:r>
+                    <m:d>
+                      <m:dPr>
+                        <m:ctrlPr>
+                          <a:rPr lang="en-US" b="0" i="1" smtClean="0">
+                            <a:latin typeface="Cambria Math" panose="02040503050406030204" pitchFamily="18" charset="0"/>
+                          </a:rPr>
+                        </m:ctrlPr>
+                      </m:dPr>
+                      <m:e>
+                        <m:sSup>
+                          <m:sSupPr>
+                            <m:ctrlPr>
+                              <a:rPr lang="en-US" b="0" i="1" smtClean="0">
+                                <a:latin typeface="Cambria Math" panose="02040503050406030204" pitchFamily="18" charset="0"/>
+                                <a:ea typeface="Cambria Math" panose="02040503050406030204" pitchFamily="18" charset="0"/>
+                              </a:rPr>
+                            </m:ctrlPr>
+                          </m:sSupPr>
+                          <m:e>
+                            <m:r>
+                              <a:rPr lang="en-US" b="0" i="1" smtClean="0">
+                                <a:latin typeface="Cambria Math" panose="02040503050406030204" pitchFamily="18" charset="0"/>
+                                <a:ea typeface="Cambria Math" panose="02040503050406030204" pitchFamily="18" charset="0"/>
+                              </a:rPr>
+                              <m:t>𝜇</m:t>
+                            </m:r>
+                          </m:e>
+                          <m:sup>
+                            <m:r>
+                              <a:rPr lang="en-US" b="0" i="1" smtClean="0">
+                                <a:latin typeface="Cambria Math" panose="02040503050406030204" pitchFamily="18" charset="0"/>
+                              </a:rPr>
+                              <m:t>−</m:t>
+                            </m:r>
+                          </m:sup>
+                        </m:sSup>
+                        <m:sSup>
+                          <m:sSupPr>
+                            <m:ctrlPr>
+                              <a:rPr lang="en-US" b="0" i="1" smtClean="0">
+                                <a:latin typeface="Cambria Math" panose="02040503050406030204" pitchFamily="18" charset="0"/>
+                              </a:rPr>
+                            </m:ctrlPr>
+                          </m:sSupPr>
+                          <m:e>
+                            <m:r>
+                              <a:rPr lang="en-US" b="0" i="1" smtClean="0">
+                                <a:latin typeface="Cambria Math" panose="02040503050406030204" pitchFamily="18" charset="0"/>
+                              </a:rPr>
+                              <m:t>𝑒</m:t>
+                            </m:r>
+                          </m:e>
+                          <m:sup>
+                            <m:r>
+                              <a:rPr lang="en-US" b="0" i="1" smtClean="0">
+                                <a:latin typeface="Cambria Math" panose="02040503050406030204" pitchFamily="18" charset="0"/>
+                              </a:rPr>
+                              <m:t>−</m:t>
+                            </m:r>
+                          </m:sup>
+                        </m:sSup>
+                        <m:r>
+                          <a:rPr lang="en-US" b="0" i="1" smtClean="0">
+                            <a:latin typeface="Cambria Math" panose="02040503050406030204" pitchFamily="18" charset="0"/>
+                            <a:ea typeface="Cambria Math" panose="02040503050406030204" pitchFamily="18" charset="0"/>
+                          </a:rPr>
+                          <m:t>→</m:t>
+                        </m:r>
+                        <m:sSup>
+                          <m:sSupPr>
+                            <m:ctrlPr>
+                              <a:rPr lang="en-US" b="0" i="1" smtClean="0">
+                                <a:latin typeface="Cambria Math" panose="02040503050406030204" pitchFamily="18" charset="0"/>
+                                <a:ea typeface="Cambria Math" panose="02040503050406030204" pitchFamily="18" charset="0"/>
+                              </a:rPr>
+                            </m:ctrlPr>
+                          </m:sSupPr>
+                          <m:e>
+                            <m:r>
+                              <a:rPr lang="en-US" b="0" i="1" smtClean="0">
+                                <a:latin typeface="Cambria Math" panose="02040503050406030204" pitchFamily="18" charset="0"/>
+                                <a:ea typeface="Cambria Math" panose="02040503050406030204" pitchFamily="18" charset="0"/>
+                              </a:rPr>
+                              <m:t>𝑒</m:t>
+                            </m:r>
+                          </m:e>
+                          <m:sup>
+                            <m:r>
+                              <a:rPr lang="en-US" b="0" i="1" smtClean="0">
+                                <a:latin typeface="Cambria Math" panose="02040503050406030204" pitchFamily="18" charset="0"/>
+                                <a:ea typeface="Cambria Math" panose="02040503050406030204" pitchFamily="18" charset="0"/>
+                              </a:rPr>
+                              <m:t>−</m:t>
+                            </m:r>
+                          </m:sup>
+                        </m:sSup>
+                        <m:sSup>
+                          <m:sSupPr>
+                            <m:ctrlPr>
+                              <a:rPr lang="en-US" b="0" i="1" smtClean="0">
+                                <a:latin typeface="Cambria Math" panose="02040503050406030204" pitchFamily="18" charset="0"/>
+                                <a:ea typeface="Cambria Math" panose="02040503050406030204" pitchFamily="18" charset="0"/>
+                              </a:rPr>
+                            </m:ctrlPr>
+                          </m:sSupPr>
+                          <m:e>
+                            <m:r>
+                              <a:rPr lang="en-US" b="0" i="1" smtClean="0">
+                                <a:latin typeface="Cambria Math" panose="02040503050406030204" pitchFamily="18" charset="0"/>
+                                <a:ea typeface="Cambria Math" panose="02040503050406030204" pitchFamily="18" charset="0"/>
+                              </a:rPr>
+                              <m:t>𝑒</m:t>
+                            </m:r>
+                          </m:e>
+                          <m:sup>
+                            <m:r>
+                              <a:rPr lang="en-US" b="0" i="1" smtClean="0">
+                                <a:latin typeface="Cambria Math" panose="02040503050406030204" pitchFamily="18" charset="0"/>
+                                <a:ea typeface="Cambria Math" panose="02040503050406030204" pitchFamily="18" charset="0"/>
+                              </a:rPr>
+                              <m:t>−</m:t>
+                            </m:r>
+                          </m:sup>
+                        </m:sSup>
+                      </m:e>
+                    </m:d>
+                    <m:r>
+                      <a:rPr lang="en-US" b="0" i="1" smtClean="0">
+                        <a:latin typeface="Cambria Math" panose="02040503050406030204" pitchFamily="18" charset="0"/>
+                        <a:ea typeface="Cambria Math" panose="02040503050406030204" pitchFamily="18" charset="0"/>
+                      </a:rPr>
+                      <m:t>=1.0×</m:t>
+                    </m:r>
+                    <m:sSup>
+                      <m:sSupPr>
+                        <m:ctrlPr>
+                          <a:rPr lang="en-US" b="0" i="1" smtClean="0">
+                            <a:latin typeface="Cambria Math" panose="02040503050406030204" pitchFamily="18" charset="0"/>
+                            <a:ea typeface="Cambria Math" panose="02040503050406030204" pitchFamily="18" charset="0"/>
+                          </a:rPr>
+                        </m:ctrlPr>
+                      </m:sSupPr>
+                      <m:e>
+                        <m:r>
+                          <a:rPr lang="en-US" b="0" i="1" smtClean="0">
+                            <a:latin typeface="Cambria Math" panose="02040503050406030204" pitchFamily="18" charset="0"/>
+                            <a:ea typeface="Cambria Math" panose="02040503050406030204" pitchFamily="18" charset="0"/>
+                          </a:rPr>
+                          <m:t>10</m:t>
+                        </m:r>
+                      </m:e>
+                      <m:sup>
+                        <m:r>
+                          <a:rPr lang="en-US" b="0" i="1" smtClean="0">
+                            <a:latin typeface="Cambria Math" panose="02040503050406030204" pitchFamily="18" charset="0"/>
+                            <a:ea typeface="Cambria Math" panose="02040503050406030204" pitchFamily="18" charset="0"/>
+                          </a:rPr>
+                          <m:t>−12</m:t>
+                        </m:r>
+                      </m:sup>
+                    </m:sSup>
+                  </m:oMath>
+                </a14:m>
+                <a:r>
+                  <a:rPr lang="en-US" dirty="0"/>
+                  <a:t> branching ratio from Sindrum II analogous process</a:t>
+                </a:r>
+              </a:p>
+              <a:p>
+                <a:pPr lvl="1"/>
+                <a:endParaRPr lang="en-US" dirty="0"/>
+              </a:p>
+              <a:p>
+                <a:pPr lvl="1"/>
+                <a:endParaRPr lang="en-US" dirty="0"/>
+              </a:p>
+              <a:p>
+                <a:pPr marL="457200" lvl="1" indent="0">
+                  <a:buNone/>
+                </a:pPr>
+                <a:endParaRPr lang="en-US" dirty="0"/>
+              </a:p>
+              <a:p>
+                <a:pPr lvl="1"/>
+                <a:r>
+                  <a:rPr lang="en-US" dirty="0"/>
+                  <a:t>For 90% confidence interval </a:t>
+                </a:r>
+                <a14:m>
+                  <m:oMath xmlns:m="http://schemas.openxmlformats.org/officeDocument/2006/math">
+                    <m:sSub>
+                      <m:sSubPr>
+                        <m:ctrlPr>
+                          <a:rPr lang="en-US" b="0" i="1" smtClean="0">
+                            <a:latin typeface="Cambria Math" panose="02040503050406030204" pitchFamily="18" charset="0"/>
+                          </a:rPr>
+                        </m:ctrlPr>
+                      </m:sSubPr>
+                      <m:e>
+                        <m:r>
+                          <a:rPr lang="en-US" b="0" i="1" smtClean="0">
+                            <a:latin typeface="Cambria Math" panose="02040503050406030204" pitchFamily="18" charset="0"/>
+                          </a:rPr>
+                          <m:t>𝑁</m:t>
+                        </m:r>
+                      </m:e>
+                      <m:sub>
+                        <m:r>
+                          <a:rPr lang="en-US" b="0" i="1" smtClean="0">
+                            <a:latin typeface="Cambria Math" panose="02040503050406030204" pitchFamily="18" charset="0"/>
+                          </a:rPr>
+                          <m:t>𝑠𝑖𝑔𝑛𝑎𝑙</m:t>
+                        </m:r>
+                      </m:sub>
+                    </m:sSub>
+                    <m:r>
+                      <a:rPr lang="en-US" b="0" i="1" smtClean="0">
+                        <a:latin typeface="Cambria Math" panose="02040503050406030204" pitchFamily="18" charset="0"/>
+                      </a:rPr>
+                      <m:t>=2.3</m:t>
+                    </m:r>
+                  </m:oMath>
+                </a14:m>
+                <a:r>
+                  <a:rPr lang="en-US" dirty="0"/>
+                  <a:t> events </a:t>
+                </a:r>
+                <a:r>
+                  <a:rPr lang="en-US" dirty="0">
+                    <a:sym typeface="Wingdings" pitchFamily="2" charset="2"/>
+                  </a:rPr>
+                  <a:t></a:t>
+                </a:r>
+                <a:endParaRPr lang="en-US" dirty="0"/>
+              </a:p>
+              <a:p>
+                <a:pPr lvl="1"/>
+                <a:r>
+                  <a:rPr lang="en-US" dirty="0"/>
+                  <a:t>For 95% confidence interval for now events showing </a:t>
+                </a:r>
+                <a14:m>
+                  <m:oMath xmlns:m="http://schemas.openxmlformats.org/officeDocument/2006/math">
+                    <m:sSub>
+                      <m:sSubPr>
+                        <m:ctrlPr>
+                          <a:rPr lang="en-US" i="1">
+                            <a:latin typeface="Cambria Math" panose="02040503050406030204" pitchFamily="18" charset="0"/>
+                          </a:rPr>
+                        </m:ctrlPr>
+                      </m:sSubPr>
+                      <m:e>
+                        <m:r>
+                          <a:rPr lang="en-US" i="1">
+                            <a:latin typeface="Cambria Math" panose="02040503050406030204" pitchFamily="18" charset="0"/>
+                          </a:rPr>
+                          <m:t>𝑁</m:t>
+                        </m:r>
+                      </m:e>
+                      <m:sub>
+                        <m:r>
+                          <a:rPr lang="en-US" i="1">
+                            <a:latin typeface="Cambria Math" panose="02040503050406030204" pitchFamily="18" charset="0"/>
+                          </a:rPr>
+                          <m:t>𝑠𝑖𝑔𝑛𝑎𝑙</m:t>
+                        </m:r>
+                      </m:sub>
+                    </m:sSub>
+                    <m:r>
+                      <a:rPr lang="en-US" i="1">
+                        <a:latin typeface="Cambria Math" panose="02040503050406030204" pitchFamily="18" charset="0"/>
+                      </a:rPr>
+                      <m:t>=</m:t>
+                    </m:r>
+                    <m:r>
+                      <a:rPr lang="en-US" b="0" i="1" smtClean="0">
+                        <a:latin typeface="Cambria Math" panose="02040503050406030204" pitchFamily="18" charset="0"/>
+                      </a:rPr>
+                      <m:t>3</m:t>
+                    </m:r>
+                  </m:oMath>
+                </a14:m>
+                <a:r>
+                  <a:rPr lang="en-US" dirty="0"/>
+                  <a:t> events</a:t>
+                </a:r>
+              </a:p>
+              <a:p>
+                <a:pPr lvl="1"/>
+                <a:r>
+                  <a:rPr lang="en-US" dirty="0"/>
+                  <a:t>For 99% confidence interval for no events showing </a:t>
+                </a:r>
+                <a14:m>
+                  <m:oMath xmlns:m="http://schemas.openxmlformats.org/officeDocument/2006/math">
+                    <m:sSub>
+                      <m:sSubPr>
+                        <m:ctrlPr>
+                          <a:rPr lang="en-US" i="1">
+                            <a:latin typeface="Cambria Math" panose="02040503050406030204" pitchFamily="18" charset="0"/>
+                          </a:rPr>
+                        </m:ctrlPr>
+                      </m:sSubPr>
+                      <m:e>
+                        <m:r>
+                          <a:rPr lang="en-US" i="1">
+                            <a:latin typeface="Cambria Math" panose="02040503050406030204" pitchFamily="18" charset="0"/>
+                          </a:rPr>
+                          <m:t>𝑁</m:t>
+                        </m:r>
+                      </m:e>
+                      <m:sub>
+                        <m:r>
+                          <a:rPr lang="en-US" i="1">
+                            <a:latin typeface="Cambria Math" panose="02040503050406030204" pitchFamily="18" charset="0"/>
+                          </a:rPr>
+                          <m:t>𝑠𝑖𝑔𝑛𝑎𝑙</m:t>
+                        </m:r>
+                      </m:sub>
+                    </m:sSub>
+                    <m:r>
+                      <a:rPr lang="en-US" i="1">
+                        <a:latin typeface="Cambria Math" panose="02040503050406030204" pitchFamily="18" charset="0"/>
+                      </a:rPr>
+                      <m:t>=</m:t>
+                    </m:r>
+                    <m:r>
+                      <a:rPr lang="en-US" b="0" i="1" smtClean="0">
+                        <a:latin typeface="Cambria Math" panose="02040503050406030204" pitchFamily="18" charset="0"/>
+                      </a:rPr>
+                      <m:t>4.6</m:t>
+                    </m:r>
+                  </m:oMath>
+                </a14:m>
+                <a:r>
+                  <a:rPr lang="en-US" dirty="0"/>
+                  <a:t> events</a:t>
+                </a:r>
+              </a:p>
+              <a:p>
+                <a:endParaRPr lang="en-US" dirty="0"/>
+              </a:p>
+            </p:txBody>
+          </p:sp>
+        </mc:Choice>
+        <mc:Fallback>
+          <p:sp>
+            <p:nvSpPr>
+              <p:cNvPr id="3" name="Content Placeholder 2">
+                <a:extLst>
+                  <a:ext uri="{FF2B5EF4-FFF2-40B4-BE49-F238E27FC236}">
+                    <a16:creationId xmlns:a16="http://schemas.microsoft.com/office/drawing/2014/main" id="{5F9290EE-BEC6-0A6E-2D4B-BA3D8AFA5182}"/>
+                  </a:ext>
+                </a:extLst>
+              </p:cNvPr>
+              <p:cNvSpPr>
+                <a:spLocks noGrp="1" noRot="1" noChangeAspect="1" noMove="1" noResize="1" noEditPoints="1" noAdjustHandles="1" noChangeArrowheads="1" noChangeShapeType="1" noTextEdit="1"/>
+              </p:cNvSpPr>
+              <p:nvPr>
+                <p:ph idx="1"/>
+              </p:nvPr>
+            </p:nvSpPr>
+            <p:spPr>
+              <a:xfrm>
+                <a:off x="0" y="574765"/>
+                <a:ext cx="12192000" cy="5781585"/>
+              </a:xfrm>
+              <a:blipFill>
+                <a:blip r:embed="rId2"/>
+                <a:stretch>
+                  <a:fillRect l="-937" t="-1974"/>
+                </a:stretch>
+              </a:blipFill>
+            </p:spPr>
+            <p:txBody>
+              <a:bodyPr/>
+              <a:lstStyle/>
+              <a:p>
+                <a:r>
+                  <a:rPr lang="en-US">
+                    <a:noFill/>
+                  </a:rPr>
+                  <a:t> </a:t>
+                </a:r>
+              </a:p>
+            </p:txBody>
+          </p:sp>
+        </mc:Fallback>
+      </mc:AlternateContent>
       <p:sp>
         <p:nvSpPr>
           <p:cNvPr id="4" name="Footer Placeholder 3">
@@ -15255,11 +15901,41 @@
                   <a:srgbClr val="C00000"/>
                 </a:solidFill>
               </a:rPr>
-              <a:t>Back-of-Envelope Wall Clock Hours Prediction (Pt. 1)</a:t>
-            </a:r>
-          </a:p>
-        </p:txBody>
-      </p:sp>
+              <a:t>Back-of-Envelope Wall Clock Hours Prediction (Pt. 2)</a:t>
+            </a:r>
+          </a:p>
+        </p:txBody>
+      </p:sp>
+      <p:pic>
+        <p:nvPicPr>
+          <p:cNvPr id="2" name="Picture 1">
+            <a:extLst>
+              <a:ext uri="{FF2B5EF4-FFF2-40B4-BE49-F238E27FC236}">
+                <a16:creationId xmlns:a16="http://schemas.microsoft.com/office/drawing/2014/main" id="{77923FF2-3374-173A-1897-48EF55C6476A}"/>
+              </a:ext>
+            </a:extLst>
+          </p:cNvPr>
+          <p:cNvPicPr>
+            <a:picLocks noChangeAspect="1"/>
+          </p:cNvPicPr>
+          <p:nvPr/>
+        </p:nvPicPr>
+        <p:blipFill>
+          <a:blip r:embed="rId3"/>
+          <a:stretch>
+            <a:fillRect/>
+          </a:stretch>
+        </p:blipFill>
+        <p:spPr>
+          <a:xfrm>
+            <a:off x="2851150" y="3465557"/>
+            <a:ext cx="6489700" cy="952500"/>
+          </a:xfrm>
+          <a:prstGeom prst="rect">
+            <a:avLst/>
+          </a:prstGeom>
+        </p:spPr>
+      </p:pic>
     </p:spTree>
     <p:extLst>
       <p:ext uri="{BB962C8B-B14F-4D97-AF65-F5344CB8AC3E}">
@@ -15316,6 +15992,16 @@
           <a:bodyPr/>
           <a:lstStyle/>
           <a:p>
+            <a:r>
+              <a:rPr lang="en-US" dirty="0"/>
+              <a:t>Lepton flavor conservation </a:t>
+            </a:r>
+            <a:r>
+              <a:rPr lang="en-US" dirty="0">
+                <a:sym typeface="Wingdings" pitchFamily="2" charset="2"/>
+              </a:rPr>
+              <a:t> “Accidental symmetry” </a:t>
+            </a:r>
             <a:endParaRPr lang="en-US" dirty="0"/>
           </a:p>
         </p:txBody>
@@ -15465,8 +16151,8 @@
           <a:chExt cx="0" cy="0"/>
         </a:xfrm>
       </p:grpSpPr>
-      <mc:AlternateContent xmlns:mc="http://schemas.openxmlformats.org/markup-compatibility/2006">
-        <mc:Choice xmlns:a14="http://schemas.microsoft.com/office/drawing/2010/main" Requires="a14">
+      <mc:AlternateContent xmlns:mc="http://schemas.openxmlformats.org/markup-compatibility/2006" xmlns:a14="http://schemas.microsoft.com/office/drawing/2010/main">
+        <mc:Choice Requires="a14">
           <p:sp>
             <p:nvSpPr>
               <p:cNvPr id="3" name="Content Placeholder 2">
@@ -15718,7 +16404,7 @@
             </p:txBody>
           </p:sp>
         </mc:Choice>
-        <mc:Fallback>
+        <mc:Fallback xmlns="">
           <p:sp>
             <p:nvSpPr>
               <p:cNvPr id="3" name="Content Placeholder 2">
@@ -16246,7 +16932,7 @@
         </p:blipFill>
         <p:spPr>
           <a:xfrm>
-            <a:off x="1289050" y="2794794"/>
+            <a:off x="1289050" y="3192541"/>
             <a:ext cx="9613900" cy="2413000"/>
           </a:xfrm>
         </p:spPr>
@@ -16308,8 +16994,8 @@
           </a:p>
         </p:txBody>
       </p:sp>
-      <mc:AlternateContent xmlns:mc="http://schemas.openxmlformats.org/markup-compatibility/2006">
-        <mc:Choice xmlns:a14="http://schemas.microsoft.com/office/drawing/2010/main" Requires="a14">
+      <mc:AlternateContent xmlns:mc="http://schemas.openxmlformats.org/markup-compatibility/2006" xmlns:a14="http://schemas.microsoft.com/office/drawing/2010/main">
+        <mc:Choice Requires="a14">
           <p:sp>
             <p:nvSpPr>
               <p:cNvPr id="3" name="Title 1">
@@ -16375,6 +17061,7 @@
                               <a:srgbClr val="C00000"/>
                             </a:solidFill>
                             <a:latin typeface="Cambria Math" panose="02040503050406030204" pitchFamily="18" charset="0"/>
+                            <a:ea typeface="Cambria Math" panose="02040503050406030204" pitchFamily="18" charset="0"/>
                           </a:rPr>
                         </m:ctrlPr>
                       </m:sSupPr>
@@ -16405,7 +17092,7 @@
                     <m:sSup>
                       <m:sSupPr>
                         <m:ctrlPr>
-                          <a:rPr lang="en-US" sz="2800" i="1" smtClean="0">
+                          <a:rPr lang="en-US" sz="2800" b="0" i="1" smtClean="0">
                             <a:solidFill>
                               <a:srgbClr val="C00000"/>
                             </a:solidFill>
@@ -16449,7 +17136,7 @@
                     <m:sSup>
                       <m:sSupPr>
                         <m:ctrlPr>
-                          <a:rPr lang="en-US" sz="2800" i="1" smtClean="0">
+                          <a:rPr lang="en-US" sz="2800" b="0" i="1" smtClean="0">
                             <a:solidFill>
                               <a:srgbClr val="C00000"/>
                             </a:solidFill>
@@ -16486,7 +17173,7 @@
                     <m:sSup>
                       <m:sSupPr>
                         <m:ctrlPr>
-                          <a:rPr lang="en-US" sz="2800" i="1" smtClean="0">
+                          <a:rPr lang="en-US" sz="2800" b="0" i="1" smtClean="0">
                             <a:solidFill>
                               <a:srgbClr val="C00000"/>
                             </a:solidFill>
@@ -16534,7 +17221,7 @@
             </p:txBody>
           </p:sp>
         </mc:Choice>
-        <mc:Fallback>
+        <mc:Fallback xmlns="">
           <p:sp>
             <p:nvSpPr>
               <p:cNvPr id="3" name="Title 1">
@@ -16579,6 +17266,149 @@
           </p:sp>
         </mc:Fallback>
       </mc:AlternateContent>
+      <p:sp>
+        <p:nvSpPr>
+          <p:cNvPr id="4" name="TextBox 3">
+            <a:extLst>
+              <a:ext uri="{FF2B5EF4-FFF2-40B4-BE49-F238E27FC236}">
+                <a16:creationId xmlns:a16="http://schemas.microsoft.com/office/drawing/2014/main" id="{B5D27E49-6FFB-42F1-53F5-D09DD74DD048}"/>
+              </a:ext>
+            </a:extLst>
+          </p:cNvPr>
+          <p:cNvSpPr txBox="1"/>
+          <p:nvPr/>
+        </p:nvSpPr>
+        <p:spPr>
+          <a:xfrm>
+            <a:off x="493594" y="936662"/>
+            <a:ext cx="11204812" cy="372361"/>
+          </a:xfrm>
+          <a:prstGeom prst="rect">
+            <a:avLst/>
+          </a:prstGeom>
+          <a:noFill/>
+        </p:spPr>
+        <p:txBody>
+          <a:bodyPr wrap="square" rtlCol="0">
+            <a:spAutoFit/>
+          </a:bodyPr>
+          <a:lstStyle/>
+          <a:p>
+            <a:r>
+              <a:rPr lang="en-US" dirty="0"/>
+              <a:t>Photonic Lagrangian: tensor vertex coupled with photonic field mixing </a:t>
+            </a:r>
+            <a:r>
+              <a:rPr lang="en-US" dirty="0" err="1"/>
+              <a:t>chiralities</a:t>
+            </a:r>
+            <a:endParaRPr lang="en-US" dirty="0"/>
+          </a:p>
+        </p:txBody>
+      </p:sp>
+      <p:sp>
+        <p:nvSpPr>
+          <p:cNvPr id="5" name="TextBox 4">
+            <a:extLst>
+              <a:ext uri="{FF2B5EF4-FFF2-40B4-BE49-F238E27FC236}">
+                <a16:creationId xmlns:a16="http://schemas.microsoft.com/office/drawing/2014/main" id="{58715DCF-31E4-AE9E-B9FB-F82433789B44}"/>
+              </a:ext>
+            </a:extLst>
+          </p:cNvPr>
+          <p:cNvSpPr txBox="1"/>
+          <p:nvPr/>
+        </p:nvSpPr>
+        <p:spPr>
+          <a:xfrm>
+            <a:off x="682388" y="2072400"/>
+            <a:ext cx="10671412" cy="369332"/>
+          </a:xfrm>
+          <a:prstGeom prst="rect">
+            <a:avLst/>
+          </a:prstGeom>
+          <a:noFill/>
+        </p:spPr>
+        <p:txBody>
+          <a:bodyPr wrap="square" rtlCol="0">
+            <a:spAutoFit/>
+          </a:bodyPr>
+          <a:lstStyle/>
+          <a:p>
+            <a:r>
+              <a:rPr lang="en-US" dirty="0"/>
+              <a:t>Contact Lagrangian: scalar and vector structures, four-point interaction mixing </a:t>
+            </a:r>
+            <a:r>
+              <a:rPr lang="en-US" dirty="0" err="1"/>
+              <a:t>chiralities</a:t>
+            </a:r>
+            <a:r>
+              <a:rPr lang="en-US" dirty="0"/>
+              <a:t> </a:t>
+            </a:r>
+          </a:p>
+        </p:txBody>
+      </p:sp>
+      <p:pic>
+        <p:nvPicPr>
+          <p:cNvPr id="7" name="Picture 6">
+            <a:extLst>
+              <a:ext uri="{FF2B5EF4-FFF2-40B4-BE49-F238E27FC236}">
+                <a16:creationId xmlns:a16="http://schemas.microsoft.com/office/drawing/2014/main" id="{E7363DAB-F955-EF43-21E1-413D125E6D9F}"/>
+              </a:ext>
+            </a:extLst>
+          </p:cNvPr>
+          <p:cNvPicPr>
+            <a:picLocks noChangeAspect="1"/>
+          </p:cNvPicPr>
+          <p:nvPr/>
+        </p:nvPicPr>
+        <p:blipFill>
+          <a:blip r:embed="rId4"/>
+          <a:stretch>
+            <a:fillRect/>
+          </a:stretch>
+        </p:blipFill>
+        <p:spPr>
+          <a:xfrm>
+            <a:off x="3543015" y="298315"/>
+            <a:ext cx="4950157" cy="619692"/>
+          </a:xfrm>
+          <a:prstGeom prst="rect">
+            <a:avLst/>
+          </a:prstGeom>
+        </p:spPr>
+      </p:pic>
+      <p:pic>
+        <p:nvPicPr>
+          <p:cNvPr id="10" name="Picture 9">
+            <a:extLst>
+              <a:ext uri="{FF2B5EF4-FFF2-40B4-BE49-F238E27FC236}">
+                <a16:creationId xmlns:a16="http://schemas.microsoft.com/office/drawing/2014/main" id="{8980FD3B-7FB7-71EC-104A-7F836A62C090}"/>
+              </a:ext>
+            </a:extLst>
+          </p:cNvPr>
+          <p:cNvPicPr>
+            <a:picLocks noChangeAspect="1"/>
+          </p:cNvPicPr>
+          <p:nvPr/>
+        </p:nvPicPr>
+        <p:blipFill>
+          <a:blip r:embed="rId5"/>
+          <a:stretch>
+            <a:fillRect/>
+          </a:stretch>
+        </p:blipFill>
+        <p:spPr>
+          <a:xfrm>
+            <a:off x="2209800" y="1438648"/>
+            <a:ext cx="7772400" cy="359745"/>
+          </a:xfrm>
+          <a:prstGeom prst="rect">
+            <a:avLst/>
+          </a:prstGeom>
+        </p:spPr>
+      </p:pic>
     </p:spTree>
     <p:extLst>
       <p:ext uri="{BB962C8B-B14F-4D97-AF65-F5344CB8AC3E}">

</xml_diff>